<commit_message>
Updated slides with notes
</commit_message>
<xml_diff>
--- a/docs/HealthSOA_Presentation.pptx
+++ b/docs/HealthSOA_Presentation.pptx
@@ -262,7 +262,7 @@
       </p:grpSpPr>
       <p:sp>
         <p:nvSpPr>
-          <p:cNvPr id="169744986" name="Slide Image Placeholder 1"/>
+          <p:cNvPr id="626679027" name="Slide Image Placeholder 1"/>
           <p:cNvSpPr>
             <a:spLocks noChangeAspect="1" noGrp="1" noRot="1"/>
           </p:cNvSpPr>
@@ -274,7 +274,7 @@
       </p:sp>
       <p:sp>
         <p:nvSpPr>
-          <p:cNvPr id="859972606" name="Notes Placeholder 2"/>
+          <p:cNvPr id="2059495477" name="Notes Placeholder 2"/>
           <p:cNvSpPr>
             <a:spLocks noGrp="1"/>
           </p:cNvSpPr>
@@ -296,7 +296,7 @@
       </p:sp>
       <p:sp>
         <p:nvSpPr>
-          <p:cNvPr id="144314081" name="Slide Number Placeholder 3"/>
+          <p:cNvPr id="1587746254" name="Slide Number Placeholder 3"/>
           <p:cNvSpPr>
             <a:spLocks noGrp="1"/>
           </p:cNvSpPr>
@@ -347,7 +347,7 @@
       </p:grpSpPr>
       <p:sp>
         <p:nvSpPr>
-          <p:cNvPr id="1175474767" name="Slide Image Placeholder 1"/>
+          <p:cNvPr id="612980227" name="Slide Image Placeholder 1"/>
           <p:cNvSpPr>
             <a:spLocks noChangeAspect="1" noGrp="1" noRot="1"/>
           </p:cNvSpPr>
@@ -359,7 +359,7 @@
       </p:sp>
       <p:sp>
         <p:nvSpPr>
-          <p:cNvPr id="828845072" name="Notes Placeholder 2"/>
+          <p:cNvPr id="234317152" name="Notes Placeholder 2"/>
           <p:cNvSpPr>
             <a:spLocks noGrp="1"/>
           </p:cNvSpPr>
@@ -375,13 +375,289 @@
             <a:pPr>
               <a:defRPr/>
             </a:pPr>
+            <a:r>
+              <a:rPr lang="it-IT" sz="1400"/>
+              <a:t>Now l</a:t>
+            </a:r>
+            <a:r>
+              <a:rPr sz="1400"/>
+              <a:t>et’s look at our Key Data Structures to see how our data is managed by </a:t>
+            </a:r>
+            <a:r>
+              <a:rPr lang="it-IT" sz="1400"/>
+              <a:t>all </a:t>
+            </a:r>
+            <a:r>
+              <a:rPr sz="1400"/>
+              <a:t>the components I just described.</a:t>
+            </a:r>
+            <a:endParaRPr sz="1400"/>
+          </a:p>
+          <a:p>
+            <a:pPr marL="239821" indent="-239821">
+              <a:buFont typeface="Arial"/>
+              <a:buChar char="•"/>
+              <a:defRPr/>
+            </a:pPr>
+            <a:r>
+              <a:rPr sz="1400"/>
+              <a:t>On the left side we </a:t>
+            </a:r>
+            <a:r>
+              <a:rPr lang="it-IT" sz="1400"/>
+              <a:t>can see</a:t>
+            </a:r>
+            <a:r>
+              <a:rPr lang="it-IT" sz="1400"/>
+              <a:t> </a:t>
+            </a:r>
+            <a:r>
+              <a:rPr sz="1400"/>
+              <a:t>the </a:t>
+            </a:r>
+            <a:r>
+              <a:rPr sz="1400" b="1"/>
+              <a:t>Domain Objects</a:t>
+            </a:r>
+            <a:r>
+              <a:rPr lang="it-IT" sz="1400"/>
+              <a:t>, t</a:t>
+            </a:r>
+            <a:r>
+              <a:rPr sz="1400"/>
+              <a:t>hese are the simple data units managed by our providers, such as patient</a:t>
+            </a:r>
+            <a:r>
+              <a:rPr lang="it-IT" sz="1400"/>
+              <a:t>s</a:t>
+            </a:r>
+            <a:r>
+              <a:rPr sz="1400"/>
+              <a:t>, conditions, allergies a</a:t>
+            </a:r>
+            <a:r>
+              <a:rPr lang="it-IT" sz="1400"/>
+              <a:t>nd </a:t>
+            </a:r>
+            <a:r>
+              <a:rPr sz="1400"/>
+              <a:t>measurements, </a:t>
+            </a:r>
+            <a:r>
+              <a:rPr lang="it-IT" sz="1400"/>
+              <a:t>each one of them with all of their</a:t>
+            </a:r>
+            <a:r>
+              <a:rPr lang="it-IT" sz="1400"/>
+              <a:t> </a:t>
+            </a:r>
+            <a:r>
+              <a:rPr sz="1400"/>
+              <a:t>attributes on screen.</a:t>
+            </a:r>
+            <a:endParaRPr sz="1400"/>
+          </a:p>
+          <a:p>
+            <a:pPr marL="239821" indent="-239821">
+              <a:buFont typeface="Arial"/>
+              <a:buChar char="•"/>
+              <a:defRPr/>
+            </a:pPr>
+            <a:r>
+              <a:rPr sz="1400"/>
+              <a:t>On the right side we have the </a:t>
+            </a:r>
+            <a:r>
+              <a:rPr sz="1400" b="1"/>
+              <a:t>Composed Objects</a:t>
+            </a:r>
+            <a:r>
+              <a:rPr sz="1400"/>
+              <a:t> created by our Prosumers.</a:t>
+            </a:r>
+            <a:r>
+              <a:rPr lang="it-IT" sz="1400"/>
+              <a:t> </a:t>
+            </a:r>
+            <a:r>
+              <a:rPr lang="it-IT" sz="1400"/>
+              <a:t>T</a:t>
+            </a:r>
+            <a:r>
+              <a:rPr sz="1400"/>
+              <a:t>he Diagnostic Bundle and the Clinical Profile represent the first level of </a:t>
+            </a:r>
+            <a:r>
+              <a:rPr lang="it-IT" sz="1400"/>
+              <a:t>composed</a:t>
+            </a:r>
+            <a:r>
+              <a:rPr lang="it-IT" sz="1400"/>
+              <a:t> data</a:t>
+            </a:r>
+            <a:r>
+              <a:rPr lang="it-IT" sz="1400"/>
+              <a:t>, respectively managed by the Diagnostic and Clinical aggregators.</a:t>
+            </a:r>
+            <a:endParaRPr sz="1400"/>
+          </a:p>
+          <a:p>
+            <a:pPr marL="239821" indent="-239821">
+              <a:buFont typeface="Arial"/>
+              <a:buChar char="•"/>
+              <a:defRPr/>
+            </a:pPr>
+            <a:r>
+              <a:rPr sz="1400"/>
+              <a:t>A</a:t>
+            </a:r>
+            <a:r>
+              <a:rPr lang="it-IT" sz="1400"/>
+              <a:t>nother</a:t>
+            </a:r>
+            <a:r>
+              <a:rPr sz="1400"/>
+              <a:t> important </a:t>
+            </a:r>
+            <a:r>
+              <a:rPr lang="it-IT" sz="1400"/>
+              <a:t>data </a:t>
+            </a:r>
+            <a:r>
+              <a:rPr sz="1400"/>
+              <a:t>structure</a:t>
+            </a:r>
+            <a:r>
+              <a:rPr lang="it-IT" sz="1400"/>
+              <a:t> </a:t>
+            </a:r>
+            <a:r>
+              <a:rPr sz="1400"/>
+              <a:t>is the Risk Flag</a:t>
+            </a:r>
+            <a:r>
+              <a:rPr lang="it-IT" sz="1400"/>
+              <a:t>, they ar</a:t>
+            </a:r>
+            <a:r>
+              <a:rPr sz="1400"/>
+              <a:t>e </a:t>
+            </a:r>
+            <a:r>
+              <a:rPr lang="it-IT" sz="1400"/>
+              <a:t> managed by the </a:t>
+            </a:r>
+            <a:r>
+              <a:rPr sz="1400"/>
+              <a:t>Care Coordinator</a:t>
+            </a:r>
+            <a:r>
+              <a:rPr lang="it-IT" sz="1400"/>
+              <a:t>, which </a:t>
+            </a:r>
+            <a:r>
+              <a:rPr sz="1400"/>
+              <a:t>creates these flags automatically if it detects a dangerous situation. For example, if a doctor prescribes a drug that conflicts with a patient's allergy, or if a lab</a:t>
+            </a:r>
+            <a:r>
+              <a:rPr lang="it-IT" sz="1400"/>
+              <a:t>oratory</a:t>
+            </a:r>
+            <a:r>
+              <a:rPr sz="1400"/>
+              <a:t> test value is criti</a:t>
+            </a:r>
+            <a:r>
+              <a:rPr sz="1400"/>
+              <a:t>cally bad, the system generates a warning flag.</a:t>
+            </a:r>
+            <a:endParaRPr sz="1400"/>
+          </a:p>
+          <a:p>
+            <a:pPr marL="239821" indent="-239821">
+              <a:buFont typeface="Arial"/>
+              <a:buChar char="•"/>
+              <a:defRPr/>
+            </a:pPr>
+            <a:r>
+              <a:rPr sz="1400"/>
+              <a:t>All of this information is packed into the final Fitness Report</a:t>
+            </a:r>
+            <a:r>
+              <a:rPr lang="it-IT" sz="1400"/>
+              <a:t>, which gives</a:t>
+            </a:r>
+            <a:r>
+              <a:rPr lang="it-IT" sz="1400"/>
+              <a:t> to </a:t>
+            </a:r>
+            <a:r>
+              <a:rPr sz="1400"/>
+              <a:t>the doctor a clear evaluation summary</a:t>
+            </a:r>
+            <a:r>
+              <a:rPr lang="it-IT" sz="1400"/>
+              <a:t>, and it can assume 3 values</a:t>
+            </a:r>
+            <a:r>
+              <a:rPr lang="it-IT" sz="1400"/>
+              <a:t>: “</a:t>
+            </a:r>
+            <a:r>
+              <a:rPr sz="1400"/>
+              <a:t>Fit</a:t>
+            </a:r>
+            <a:r>
+              <a:rPr lang="it-IT" sz="1400"/>
+              <a:t>”</a:t>
+            </a:r>
+            <a:r>
+              <a:rPr sz="1400"/>
+              <a:t>, </a:t>
+            </a:r>
+            <a:r>
+              <a:rPr lang="it-IT" sz="1400"/>
+              <a:t>“</a:t>
+            </a:r>
+            <a:r>
+              <a:rPr sz="1400"/>
+              <a:t>Fit with Reservation</a:t>
+            </a:r>
+            <a:r>
+              <a:rPr lang="it-IT" sz="1400"/>
+              <a:t>”</a:t>
+            </a:r>
+            <a:r>
+              <a:rPr sz="1400"/>
+              <a:t> or </a:t>
+            </a:r>
+            <a:r>
+              <a:rPr lang="it-IT" sz="1400"/>
+              <a:t>“</a:t>
+            </a:r>
+            <a:r>
+              <a:rPr sz="1400"/>
+              <a:t>Unfit</a:t>
+            </a:r>
+            <a:r>
+              <a:rPr lang="it-IT" sz="1400"/>
+              <a:t>”</a:t>
+            </a:r>
+            <a:r>
+              <a:rPr lang="it-IT" sz="1400"/>
+              <a:t>,</a:t>
+            </a:r>
+            <a:r>
+              <a:rPr sz="1400"/>
+              <a:t> along with the patient summary and the list of risk factors.</a:t>
+            </a:r>
             <a:endParaRPr lang="en-US"/>
           </a:p>
         </p:txBody>
       </p:sp>
       <p:sp>
         <p:nvSpPr>
-          <p:cNvPr id="1975221014" name="Slide Number Placeholder 3"/>
+          <p:cNvPr id="701688697" name="Slide Number Placeholder 3"/>
           <p:cNvSpPr>
             <a:spLocks noGrp="1"/>
           </p:cNvSpPr>
@@ -432,7 +708,7 @@
       </p:grpSpPr>
       <p:sp>
         <p:nvSpPr>
-          <p:cNvPr id="1098218929" name="Slide Image Placeholder 1"/>
+          <p:cNvPr id="789519722" name="Slide Image Placeholder 1"/>
           <p:cNvSpPr>
             <a:spLocks noChangeAspect="1" noGrp="1" noRot="1"/>
           </p:cNvSpPr>
@@ -444,7 +720,7 @@
       </p:sp>
       <p:sp>
         <p:nvSpPr>
-          <p:cNvPr id="1815162250" name="Notes Placeholder 2"/>
+          <p:cNvPr id="2114689095" name="Notes Placeholder 2"/>
           <p:cNvSpPr>
             <a:spLocks noGrp="1"/>
           </p:cNvSpPr>
@@ -466,7 +742,7 @@
       </p:sp>
       <p:sp>
         <p:nvSpPr>
-          <p:cNvPr id="153293252" name="Slide Number Placeholder 3"/>
+          <p:cNvPr id="1954071644" name="Slide Number Placeholder 3"/>
           <p:cNvSpPr>
             <a:spLocks noGrp="1"/>
           </p:cNvSpPr>
@@ -517,7 +793,7 @@
       </p:grpSpPr>
       <p:sp>
         <p:nvSpPr>
-          <p:cNvPr id="985719266" name="Slide Image Placeholder 1"/>
+          <p:cNvPr id="1583176935" name="Slide Image Placeholder 1"/>
           <p:cNvSpPr>
             <a:spLocks noChangeAspect="1" noGrp="1" noRot="1"/>
           </p:cNvSpPr>
@@ -529,7 +805,7 @@
       </p:sp>
       <p:sp>
         <p:nvSpPr>
-          <p:cNvPr id="1457928295" name="Notes Placeholder 2"/>
+          <p:cNvPr id="681379675" name="Notes Placeholder 2"/>
           <p:cNvSpPr>
             <a:spLocks noGrp="1"/>
           </p:cNvSpPr>
@@ -551,7 +827,7 @@
       </p:sp>
       <p:sp>
         <p:nvSpPr>
-          <p:cNvPr id="2116678357" name="Slide Number Placeholder 3"/>
+          <p:cNvPr id="753898833" name="Slide Number Placeholder 3"/>
           <p:cNvSpPr>
             <a:spLocks noGrp="1"/>
           </p:cNvSpPr>
@@ -602,7 +878,7 @@
       </p:grpSpPr>
       <p:sp>
         <p:nvSpPr>
-          <p:cNvPr id="668930231" name="Slide Image Placeholder 1"/>
+          <p:cNvPr id="64590185" name="Slide Image Placeholder 1"/>
           <p:cNvSpPr>
             <a:spLocks noChangeAspect="1" noGrp="1" noRot="1"/>
           </p:cNvSpPr>
@@ -614,7 +890,7 @@
       </p:sp>
       <p:sp>
         <p:nvSpPr>
-          <p:cNvPr id="726185584" name="Notes Placeholder 2"/>
+          <p:cNvPr id="267710022" name="Notes Placeholder 2"/>
           <p:cNvSpPr>
             <a:spLocks noGrp="1"/>
           </p:cNvSpPr>
@@ -636,7 +912,7 @@
       </p:sp>
       <p:sp>
         <p:nvSpPr>
-          <p:cNvPr id="549223016" name="Slide Number Placeholder 3"/>
+          <p:cNvPr id="917500280" name="Slide Number Placeholder 3"/>
           <p:cNvSpPr>
             <a:spLocks noGrp="1"/>
           </p:cNvSpPr>
@@ -687,7 +963,7 @@
       </p:grpSpPr>
       <p:sp>
         <p:nvSpPr>
-          <p:cNvPr id="903353342" name="Slide Image Placeholder 1"/>
+          <p:cNvPr id="1802872693" name="Slide Image Placeholder 1"/>
           <p:cNvSpPr>
             <a:spLocks noChangeAspect="1" noGrp="1" noRot="1"/>
           </p:cNvSpPr>
@@ -699,7 +975,7 @@
       </p:sp>
       <p:sp>
         <p:nvSpPr>
-          <p:cNvPr id="1630318219" name="Notes Placeholder 2"/>
+          <p:cNvPr id="674082157" name="Notes Placeholder 2"/>
           <p:cNvSpPr>
             <a:spLocks noGrp="1"/>
           </p:cNvSpPr>
@@ -721,7 +997,7 @@
       </p:sp>
       <p:sp>
         <p:nvSpPr>
-          <p:cNvPr id="1566126721" name="Slide Number Placeholder 3"/>
+          <p:cNvPr id="1623866983" name="Slide Number Placeholder 3"/>
           <p:cNvSpPr>
             <a:spLocks noGrp="1"/>
           </p:cNvSpPr>
@@ -772,7 +1048,7 @@
       </p:grpSpPr>
       <p:sp>
         <p:nvSpPr>
-          <p:cNvPr id="209091067" name="Slide Image Placeholder 1"/>
+          <p:cNvPr id="1884681035" name="Slide Image Placeholder 1"/>
           <p:cNvSpPr>
             <a:spLocks noChangeAspect="1" noGrp="1" noRot="1"/>
           </p:cNvSpPr>
@@ -784,7 +1060,7 @@
       </p:sp>
       <p:sp>
         <p:nvSpPr>
-          <p:cNvPr id="1049321311" name="Notes Placeholder 2"/>
+          <p:cNvPr id="1232315033" name="Notes Placeholder 2"/>
           <p:cNvSpPr>
             <a:spLocks noGrp="1"/>
           </p:cNvSpPr>
@@ -806,7 +1082,7 @@
       </p:sp>
       <p:sp>
         <p:nvSpPr>
-          <p:cNvPr id="1573553245" name="Slide Number Placeholder 3"/>
+          <p:cNvPr id="1606916827" name="Slide Number Placeholder 3"/>
           <p:cNvSpPr>
             <a:spLocks noGrp="1"/>
           </p:cNvSpPr>
@@ -857,7 +1133,7 @@
       </p:grpSpPr>
       <p:sp>
         <p:nvSpPr>
-          <p:cNvPr id="1195364731" name="Slide Image Placeholder 1"/>
+          <p:cNvPr id="46362586" name="Slide Image Placeholder 1"/>
           <p:cNvSpPr>
             <a:spLocks noChangeAspect="1" noGrp="1" noRot="1"/>
           </p:cNvSpPr>
@@ -869,7 +1145,7 @@
       </p:sp>
       <p:sp>
         <p:nvSpPr>
-          <p:cNvPr id="32560299" name="Notes Placeholder 2"/>
+          <p:cNvPr id="1321213556" name="Notes Placeholder 2"/>
           <p:cNvSpPr>
             <a:spLocks noGrp="1"/>
           </p:cNvSpPr>
@@ -891,7 +1167,7 @@
       </p:sp>
       <p:sp>
         <p:nvSpPr>
-          <p:cNvPr id="1319718078" name="Slide Number Placeholder 3"/>
+          <p:cNvPr id="1085766808" name="Slide Number Placeholder 3"/>
           <p:cNvSpPr>
             <a:spLocks noGrp="1"/>
           </p:cNvSpPr>
@@ -942,7 +1218,7 @@
       </p:grpSpPr>
       <p:sp>
         <p:nvSpPr>
-          <p:cNvPr id="1387332819" name="Slide Image Placeholder 1"/>
+          <p:cNvPr id="1476715194" name="Slide Image Placeholder 1"/>
           <p:cNvSpPr>
             <a:spLocks noChangeAspect="1" noGrp="1" noRot="1"/>
           </p:cNvSpPr>
@@ -954,7 +1230,7 @@
       </p:sp>
       <p:sp>
         <p:nvSpPr>
-          <p:cNvPr id="1074250308" name="Notes Placeholder 2"/>
+          <p:cNvPr id="1254638864" name="Notes Placeholder 2"/>
           <p:cNvSpPr>
             <a:spLocks noGrp="1"/>
           </p:cNvSpPr>
@@ -976,7 +1252,7 @@
       </p:sp>
       <p:sp>
         <p:nvSpPr>
-          <p:cNvPr id="488472410" name="Slide Number Placeholder 3"/>
+          <p:cNvPr id="1335885569" name="Slide Number Placeholder 3"/>
           <p:cNvSpPr>
             <a:spLocks noGrp="1"/>
           </p:cNvSpPr>
@@ -1027,7 +1303,7 @@
       </p:grpSpPr>
       <p:sp>
         <p:nvSpPr>
-          <p:cNvPr id="816500414" name="Slide Image Placeholder 1"/>
+          <p:cNvPr id="588945216" name="Slide Image Placeholder 1"/>
           <p:cNvSpPr>
             <a:spLocks noChangeAspect="1" noGrp="1" noRot="1"/>
           </p:cNvSpPr>
@@ -1039,7 +1315,7 @@
       </p:sp>
       <p:sp>
         <p:nvSpPr>
-          <p:cNvPr id="406529995" name="Notes Placeholder 2"/>
+          <p:cNvPr id="1314490418" name="Notes Placeholder 2"/>
           <p:cNvSpPr>
             <a:spLocks noGrp="1"/>
           </p:cNvSpPr>
@@ -1061,7 +1337,7 @@
       </p:sp>
       <p:sp>
         <p:nvSpPr>
-          <p:cNvPr id="330512381" name="Slide Number Placeholder 3"/>
+          <p:cNvPr id="1207404741" name="Slide Number Placeholder 3"/>
           <p:cNvSpPr>
             <a:spLocks noGrp="1"/>
           </p:cNvSpPr>
@@ -1112,7 +1388,7 @@
       </p:grpSpPr>
       <p:sp>
         <p:nvSpPr>
-          <p:cNvPr id="866668698" name="Slide Image Placeholder 1"/>
+          <p:cNvPr id="2009097908" name="Slide Image Placeholder 1"/>
           <p:cNvSpPr>
             <a:spLocks noChangeAspect="1" noGrp="1" noRot="1"/>
           </p:cNvSpPr>
@@ -1124,7 +1400,7 @@
       </p:sp>
       <p:sp>
         <p:nvSpPr>
-          <p:cNvPr id="2010899150" name="Notes Placeholder 2"/>
+          <p:cNvPr id="11270481" name="Notes Placeholder 2"/>
           <p:cNvSpPr>
             <a:spLocks noGrp="1"/>
           </p:cNvSpPr>
@@ -1146,7 +1422,7 @@
       </p:sp>
       <p:sp>
         <p:nvSpPr>
-          <p:cNvPr id="1571960396" name="Slide Number Placeholder 3"/>
+          <p:cNvPr id="272092279" name="Slide Number Placeholder 3"/>
           <p:cNvSpPr>
             <a:spLocks noGrp="1"/>
           </p:cNvSpPr>
@@ -1197,7 +1473,7 @@
       </p:grpSpPr>
       <p:sp>
         <p:nvSpPr>
-          <p:cNvPr id="245553608" name="Slide Image Placeholder 1"/>
+          <p:cNvPr id="1949798686" name="Slide Image Placeholder 1"/>
           <p:cNvSpPr>
             <a:spLocks noChangeAspect="1" noGrp="1" noRot="1"/>
           </p:cNvSpPr>
@@ -1209,7 +1485,7 @@
       </p:sp>
       <p:sp>
         <p:nvSpPr>
-          <p:cNvPr id="755334815" name="Notes Placeholder 2"/>
+          <p:cNvPr id="523295485" name="Notes Placeholder 2"/>
           <p:cNvSpPr>
             <a:spLocks noGrp="1"/>
           </p:cNvSpPr>
@@ -1231,7 +1507,7 @@
       </p:sp>
       <p:sp>
         <p:nvSpPr>
-          <p:cNvPr id="1091391081" name="Slide Number Placeholder 3"/>
+          <p:cNvPr id="880832283" name="Slide Number Placeholder 3"/>
           <p:cNvSpPr>
             <a:spLocks noGrp="1"/>
           </p:cNvSpPr>
@@ -1282,7 +1558,7 @@
       </p:grpSpPr>
       <p:sp>
         <p:nvSpPr>
-          <p:cNvPr id="2128484596" name="Slide Image Placeholder 1"/>
+          <p:cNvPr id="1329736853" name="Slide Image Placeholder 1"/>
           <p:cNvSpPr>
             <a:spLocks noChangeAspect="1" noGrp="1" noRot="1"/>
           </p:cNvSpPr>
@@ -1294,7 +1570,7 @@
       </p:sp>
       <p:sp>
         <p:nvSpPr>
-          <p:cNvPr id="1964816182" name="Notes Placeholder 2"/>
+          <p:cNvPr id="1972648332" name="Notes Placeholder 2"/>
           <p:cNvSpPr>
             <a:spLocks noGrp="1"/>
           </p:cNvSpPr>
@@ -1316,7 +1592,7 @@
       </p:sp>
       <p:sp>
         <p:nvSpPr>
-          <p:cNvPr id="1977112393" name="Slide Number Placeholder 3"/>
+          <p:cNvPr id="1082747887" name="Slide Number Placeholder 3"/>
           <p:cNvSpPr>
             <a:spLocks noGrp="1"/>
           </p:cNvSpPr>
@@ -1367,7 +1643,7 @@
       </p:grpSpPr>
       <p:sp>
         <p:nvSpPr>
-          <p:cNvPr id="1698628116" name="Slide Image Placeholder 1"/>
+          <p:cNvPr id="1094231523" name="Slide Image Placeholder 1"/>
           <p:cNvSpPr>
             <a:spLocks noChangeAspect="1" noGrp="1" noRot="1"/>
           </p:cNvSpPr>
@@ -1379,7 +1655,7 @@
       </p:sp>
       <p:sp>
         <p:nvSpPr>
-          <p:cNvPr id="1593560299" name="Notes Placeholder 2"/>
+          <p:cNvPr id="1629396721" name="Notes Placeholder 2"/>
           <p:cNvSpPr>
             <a:spLocks noGrp="1"/>
           </p:cNvSpPr>
@@ -1401,7 +1677,7 @@
       </p:sp>
       <p:sp>
         <p:nvSpPr>
-          <p:cNvPr id="1678338695" name="Slide Number Placeholder 3"/>
+          <p:cNvPr id="1005857041" name="Slide Number Placeholder 3"/>
           <p:cNvSpPr>
             <a:spLocks noGrp="1"/>
           </p:cNvSpPr>
@@ -1452,7 +1728,7 @@
       </p:grpSpPr>
       <p:sp>
         <p:nvSpPr>
-          <p:cNvPr id="677839712" name="Slide Image Placeholder 1"/>
+          <p:cNvPr id="976210321" name="Slide Image Placeholder 1"/>
           <p:cNvSpPr>
             <a:spLocks noChangeAspect="1" noGrp="1" noRot="1"/>
           </p:cNvSpPr>
@@ -1464,7 +1740,7 @@
       </p:sp>
       <p:sp>
         <p:nvSpPr>
-          <p:cNvPr id="1147920620" name="Notes Placeholder 2"/>
+          <p:cNvPr id="1819560302" name="Notes Placeholder 2"/>
           <p:cNvSpPr>
             <a:spLocks noGrp="1"/>
           </p:cNvSpPr>
@@ -1480,13 +1756,53 @@
             <a:pPr>
               <a:defRPr/>
             </a:pPr>
+            <a:r>
+              <a:rPr sz="1400"/>
+              <a:t>Thank you, Edoardo.</a:t>
+            </a:r>
+            <a:r>
+              <a:rPr lang="it-IT" sz="1400"/>
+              <a:t> </a:t>
+            </a:r>
+            <a:r>
+              <a:rPr sz="1400"/>
+              <a:t>Now, we will now look at</a:t>
+            </a:r>
+            <a:r>
+              <a:rPr lang="it-IT" sz="1400"/>
+              <a:t> the second block</a:t>
+            </a:r>
+            <a:r>
+              <a:rPr sz="1400"/>
+              <a:t> of our presentation. In this section, I will explain the business components of our system</a:t>
+            </a:r>
+            <a:r>
+              <a:rPr lang="it-IT" sz="1400"/>
+              <a:t>, w</a:t>
+            </a:r>
+            <a:r>
+              <a:rPr lang="it-IT" sz="1400"/>
+              <a:t>e’</a:t>
+            </a:r>
+            <a:r>
+              <a:rPr sz="1400"/>
+              <a:t>ll see who are the main </a:t>
+            </a:r>
+            <a:r>
+              <a:rPr lang="it-IT" sz="1400"/>
+              <a:t>software a</a:t>
+            </a:r>
+            <a:r>
+              <a:rPr sz="1400"/>
+              <a:t>ctors, what responsibilities they have and how our data is structured.</a:t>
+            </a:r>
             <a:endParaRPr lang="en-US"/>
           </a:p>
         </p:txBody>
       </p:sp>
       <p:sp>
         <p:nvSpPr>
-          <p:cNvPr id="435891178" name="Slide Number Placeholder 3"/>
+          <p:cNvPr id="393895242" name="Slide Number Placeholder 3"/>
           <p:cNvSpPr>
             <a:spLocks noGrp="1"/>
           </p:cNvSpPr>
@@ -1537,7 +1853,7 @@
       </p:grpSpPr>
       <p:sp>
         <p:nvSpPr>
-          <p:cNvPr id="1078368908" name="Slide Image Placeholder 1"/>
+          <p:cNvPr id="1680558425" name="Slide Image Placeholder 1"/>
           <p:cNvSpPr>
             <a:spLocks noChangeAspect="1" noGrp="1" noRot="1"/>
           </p:cNvSpPr>
@@ -1549,7 +1865,7 @@
       </p:sp>
       <p:sp>
         <p:nvSpPr>
-          <p:cNvPr id="665071754" name="Notes Placeholder 2"/>
+          <p:cNvPr id="613564763" name="Notes Placeholder 2"/>
           <p:cNvSpPr>
             <a:spLocks noGrp="1"/>
           </p:cNvSpPr>
@@ -1565,13 +1881,305 @@
             <a:pPr>
               <a:defRPr/>
             </a:pPr>
+            <a:r>
+              <a:rPr sz="1400"/>
+              <a:t>On this slide, we have the Service Providers</a:t>
+            </a:r>
+            <a:r>
+              <a:rPr lang="it-IT" sz="1400"/>
+              <a:t> which </a:t>
+            </a:r>
+            <a:r>
+              <a:rPr sz="1400"/>
+              <a:t>are the foundational services of our platform. Each provider is independent</a:t>
+            </a:r>
+            <a:r>
+              <a:rPr lang="it-IT" sz="1400"/>
+              <a:t> from the others</a:t>
+            </a:r>
+            <a:r>
+              <a:rPr sz="1400"/>
+              <a:t>, manages its own specific da</a:t>
+            </a:r>
+            <a:r>
+              <a:rPr lang="it-IT" sz="1400"/>
+              <a:t>ta </a:t>
+            </a:r>
+            <a:r>
+              <a:rPr sz="1400"/>
+              <a:t>and has its own separate database to ensure decoupling.</a:t>
+            </a:r>
+            <a:endParaRPr sz="1400"/>
+          </a:p>
+          <a:p>
+            <a:pPr>
+              <a:defRPr/>
+            </a:pPr>
+            <a:r>
+              <a:rPr sz="1400"/>
+              <a:t>We have </a:t>
+            </a:r>
+            <a:r>
+              <a:rPr lang="it-IT" sz="1400" b="1"/>
+              <a:t>4</a:t>
+            </a:r>
+            <a:r>
+              <a:rPr sz="1400" b="1"/>
+              <a:t> providers</a:t>
+            </a:r>
+            <a:r>
+              <a:rPr sz="1400"/>
+              <a:t> in total:</a:t>
+            </a:r>
+            <a:endParaRPr/>
+          </a:p>
+          <a:p>
+            <a:pPr marL="239821" indent="-239821">
+              <a:buFont typeface="Arial"/>
+              <a:buChar char="•"/>
+              <a:defRPr/>
+            </a:pPr>
+            <a:r>
+              <a:rPr sz="1400"/>
+              <a:t>First</a:t>
+            </a:r>
+            <a:r>
+              <a:rPr lang="it-IT" sz="1400"/>
+              <a:t> we have</a:t>
+            </a:r>
+            <a:r>
+              <a:rPr sz="1400"/>
+              <a:t> the </a:t>
+            </a:r>
+            <a:r>
+              <a:rPr sz="1400" b="1"/>
+              <a:t>Anagrafe Service</a:t>
+            </a:r>
+            <a:r>
+              <a:rPr lang="it-IT" sz="1400"/>
+              <a:t>, which </a:t>
+            </a:r>
+            <a:r>
+              <a:rPr sz="1400"/>
+              <a:t>simulates an external registry</a:t>
+            </a:r>
+            <a:r>
+              <a:rPr lang="it-IT" sz="1400"/>
+              <a:t> </a:t>
+            </a:r>
+            <a:r>
+              <a:rPr sz="1400"/>
+              <a:t>manag</a:t>
+            </a:r>
+            <a:r>
+              <a:rPr lang="it-IT" sz="1400"/>
+              <a:t>ing</a:t>
+            </a:r>
+            <a:r>
+              <a:rPr sz="1400"/>
+              <a:t> patient details, medical history and allergies. Because it simulates a real-world legacy system, it uses the SOAP protocol instead of the more modern REST</a:t>
+            </a:r>
+            <a:r>
+              <a:rPr lang="it-IT" sz="1400"/>
+              <a:t> to send its data.</a:t>
+            </a:r>
+            <a:endParaRPr sz="1400"/>
+          </a:p>
+          <a:p>
+            <a:pPr marL="239821" indent="-239821">
+              <a:buFont typeface="Arial"/>
+              <a:buChar char="•"/>
+              <a:defRPr/>
+            </a:pPr>
+            <a:r>
+              <a:rPr sz="1400"/>
+              <a:t>Next, we have three modern REST services. </a:t>
+            </a:r>
+            <a:r>
+              <a:rPr lang="it-IT" sz="1400"/>
+              <a:t>Starting from the</a:t>
+            </a:r>
+            <a:r>
+              <a:rPr lang="it-IT" sz="1400"/>
+              <a:t> </a:t>
+            </a:r>
+            <a:r>
+              <a:rPr sz="1400" b="1"/>
+              <a:t>Laboratorio Service</a:t>
+            </a:r>
+            <a:r>
+              <a:rPr sz="1400"/>
+              <a:t> </a:t>
+            </a:r>
+            <a:r>
+              <a:rPr lang="it-IT" sz="1400"/>
+              <a:t>which </a:t>
+            </a:r>
+            <a:r>
+              <a:rPr sz="1400"/>
+              <a:t>handles medical test orders and results. In the real world, processing a biological sample takes time</a:t>
+            </a:r>
+            <a:r>
+              <a:rPr lang="it-IT" sz="1400"/>
+              <a:t>, t</a:t>
+            </a:r>
+            <a:r>
+              <a:rPr sz="1400"/>
+              <a:t>herefore this service works asynchronously</a:t>
+            </a:r>
+            <a:r>
+              <a:rPr lang="it-IT" sz="1400"/>
+              <a:t>, </a:t>
+            </a:r>
+            <a:r>
+              <a:rPr sz="1400"/>
+              <a:t>accept</a:t>
+            </a:r>
+            <a:r>
+              <a:rPr lang="it-IT" sz="1400"/>
+              <a:t>ing </a:t>
+            </a:r>
+            <a:r>
+              <a:rPr sz="1400"/>
+              <a:t>order</a:t>
+            </a:r>
+            <a:r>
+              <a:rPr lang="it-IT" sz="1400"/>
+              <a:t>s</a:t>
+            </a:r>
+            <a:r>
+              <a:rPr sz="1400"/>
+              <a:t> immediatel</a:t>
+            </a:r>
+            <a:r>
+              <a:rPr lang="it-IT" sz="1400"/>
+              <a:t>y</a:t>
+            </a:r>
+            <a:r>
+              <a:rPr sz="1400"/>
+              <a:t> and deliver</a:t>
+            </a:r>
+            <a:r>
+              <a:rPr lang="it-IT" sz="1400"/>
+              <a:t>ing</a:t>
+            </a:r>
+            <a:r>
+              <a:rPr sz="1400"/>
+              <a:t> the results</a:t>
+            </a:r>
+            <a:r>
+              <a:rPr lang="it-IT" sz="1400"/>
+              <a:t> at a</a:t>
+            </a:r>
+            <a:r>
+              <a:rPr sz="1400"/>
+              <a:t> later</a:t>
+            </a:r>
+            <a:r>
+              <a:rPr lang="it-IT" sz="1400"/>
+              <a:t> time</a:t>
+            </a:r>
+            <a:r>
+              <a:rPr sz="1400"/>
+              <a:t>.</a:t>
+            </a:r>
+            <a:endParaRPr/>
+          </a:p>
+          <a:p>
+            <a:pPr marL="239821" indent="-239821">
+              <a:buFont typeface="Arial"/>
+              <a:buChar char="•"/>
+              <a:defRPr/>
+            </a:pPr>
+            <a:r>
+              <a:rPr sz="1400"/>
+              <a:t>The </a:t>
+            </a:r>
+            <a:r>
+              <a:rPr sz="1400" b="1"/>
+              <a:t>Imaging Service</a:t>
+            </a:r>
+            <a:r>
+              <a:rPr sz="1400"/>
+              <a:t> works exactly the same way</a:t>
+            </a:r>
+            <a:r>
+              <a:rPr lang="it-IT" sz="1400"/>
+              <a:t> as the Laboratorio Service</a:t>
+            </a:r>
+            <a:r>
+              <a:rPr sz="1400"/>
+              <a:t>, but </a:t>
+            </a:r>
+            <a:r>
+              <a:rPr lang="it-IT" sz="1400"/>
+              <a:t>instead it</a:t>
+            </a:r>
+            <a:r>
+              <a:rPr sz="1400"/>
+              <a:t> manages </a:t>
+            </a:r>
+            <a:r>
+              <a:rPr lang="it-IT" sz="1400"/>
+              <a:t>very different data such as </a:t>
+            </a:r>
+            <a:r>
+              <a:rPr sz="1400"/>
+              <a:t>radiology reports</a:t>
+            </a:r>
+            <a:r>
+              <a:rPr lang="it-IT" sz="1400"/>
+              <a:t>, X-Rays and MRI scans.</a:t>
+            </a:r>
+            <a:endParaRPr sz="1400"/>
+          </a:p>
+          <a:p>
+            <a:pPr marL="239821" indent="-239821">
+              <a:buFont typeface="Arial"/>
+              <a:buChar char="•"/>
+              <a:defRPr/>
+            </a:pPr>
+            <a:r>
+              <a:rPr sz="1400"/>
+              <a:t>Finally, the </a:t>
+            </a:r>
+            <a:r>
+              <a:rPr sz="1400" b="1"/>
+              <a:t>Farmacia Service</a:t>
+            </a:r>
+            <a:r>
+              <a:rPr sz="1400"/>
+              <a:t> manages active drug prescriptions and includes a</a:t>
+            </a:r>
+            <a:r>
+              <a:rPr lang="it-IT" sz="1400"/>
+              <a:t>n endpoint </a:t>
+            </a:r>
+            <a:r>
+              <a:rPr sz="1400"/>
+              <a:t>to check for dangerous drug interactions.</a:t>
+            </a:r>
+            <a:endParaRPr/>
+          </a:p>
+          <a:p>
+            <a:pPr>
+              <a:defRPr/>
+            </a:pPr>
+            <a:r>
+              <a:rPr sz="1400"/>
+              <a:t>Now, let’s see how we combine all this information</a:t>
+            </a:r>
+            <a:r>
+              <a:rPr lang="it-IT" sz="1400"/>
+              <a:t>s</a:t>
+            </a:r>
             <a:endParaRPr lang="en-US"/>
           </a:p>
         </p:txBody>
       </p:sp>
       <p:sp>
         <p:nvSpPr>
-          <p:cNvPr id="21859012" name="Slide Number Placeholder 3"/>
+          <p:cNvPr id="1748045876" name="Slide Number Placeholder 3"/>
           <p:cNvSpPr>
             <a:spLocks noGrp="1"/>
           </p:cNvSpPr>
@@ -1622,7 +2230,7 @@
       </p:grpSpPr>
       <p:sp>
         <p:nvSpPr>
-          <p:cNvPr id="1849141129" name="Slide Image Placeholder 1"/>
+          <p:cNvPr id="1428978981" name="Slide Image Placeholder 1"/>
           <p:cNvSpPr>
             <a:spLocks noChangeAspect="1" noGrp="1" noRot="1"/>
           </p:cNvSpPr>
@@ -1634,7 +2242,7 @@
       </p:sp>
       <p:sp>
         <p:nvSpPr>
-          <p:cNvPr id="1449431738" name="Notes Placeholder 2"/>
+          <p:cNvPr id="57913864" name="Notes Placeholder 2"/>
           <p:cNvSpPr>
             <a:spLocks noGrp="1"/>
           </p:cNvSpPr>
@@ -1650,13 +2258,233 @@
             <a:pPr>
               <a:defRPr/>
             </a:pPr>
+            <a:r>
+              <a:rPr lang="it-IT" sz="1400"/>
+              <a:t>Here are </a:t>
+            </a:r>
+            <a:r>
+              <a:rPr lang="it-IT" sz="1400"/>
+              <a:t>the</a:t>
+            </a:r>
+            <a:r>
+              <a:rPr sz="1400"/>
+              <a:t> Service Prosumers</a:t>
+            </a:r>
+            <a:r>
+              <a:rPr lang="it-IT" sz="1400"/>
+              <a:t>, </a:t>
+            </a:r>
+            <a:r>
+              <a:rPr lang="it-IT" sz="1400"/>
+              <a:t>we use them t</a:t>
+            </a:r>
+            <a:r>
+              <a:rPr sz="1400"/>
+              <a:t>o create a complete view for the clinical staff, </a:t>
+            </a:r>
+            <a:r>
+              <a:rPr lang="it-IT" sz="1400"/>
+              <a:t>therefore these</a:t>
+            </a:r>
+            <a:r>
+              <a:rPr sz="1400"/>
+              <a:t> components do not just store data but they consume data from the providers and aggregate it.</a:t>
+            </a:r>
+            <a:endParaRPr sz="1400"/>
+          </a:p>
+          <a:p>
+            <a:pPr marL="239821" indent="-239821">
+              <a:buFont typeface="Arial"/>
+              <a:buChar char="•"/>
+              <a:defRPr/>
+            </a:pPr>
+            <a:r>
+              <a:rPr sz="1400"/>
+              <a:t>The first one is the </a:t>
+            </a:r>
+            <a:r>
+              <a:rPr sz="1400" b="1"/>
+              <a:t>Diagnostic Aggregator</a:t>
+            </a:r>
+            <a:r>
+              <a:rPr lang="it-IT" sz="1400"/>
+              <a:t>, which </a:t>
+            </a:r>
+            <a:r>
+              <a:rPr sz="1400"/>
+              <a:t>communicates with the Laboratorio </a:t>
+            </a:r>
+            <a:r>
+              <a:rPr lang="it-IT" sz="1400"/>
+              <a:t>service </a:t>
+            </a:r>
+            <a:r>
+              <a:rPr sz="1400"/>
+              <a:t>and </a:t>
+            </a:r>
+            <a:r>
+              <a:rPr lang="it-IT" sz="1400"/>
+              <a:t>the </a:t>
+            </a:r>
+            <a:r>
+              <a:rPr sz="1400"/>
+              <a:t>Imaging service. It collects the asynchronous test results and combines them into a single complete Diagnostic Bundle</a:t>
+            </a:r>
+            <a:r>
+              <a:rPr lang="it-IT" sz="1400"/>
+              <a:t>, it can be customized based on the panel value selectable from the index page.</a:t>
+            </a:r>
+            <a:endParaRPr sz="1400"/>
+          </a:p>
+          <a:p>
+            <a:pPr marL="239821" indent="-239821">
+              <a:buFont typeface="Arial"/>
+              <a:buChar char="•"/>
+              <a:defRPr/>
+            </a:pPr>
+            <a:r>
+              <a:rPr sz="1400"/>
+              <a:t>The second one is the </a:t>
+            </a:r>
+            <a:r>
+              <a:rPr sz="1400" b="1"/>
+              <a:t>Clinical Aggregator</a:t>
+            </a:r>
+            <a:r>
+              <a:rPr lang="it-IT" sz="1400"/>
+              <a:t>, which</a:t>
+            </a:r>
+            <a:r>
+              <a:rPr sz="1400"/>
+              <a:t> acts as a technological bridge</a:t>
+            </a:r>
+            <a:r>
+              <a:rPr lang="it-IT" sz="1400"/>
+              <a:t> because i</a:t>
+            </a:r>
+            <a:r>
+              <a:rPr sz="1400"/>
+              <a:t>t talks to </a:t>
+            </a:r>
+            <a:r>
+              <a:rPr lang="it-IT" sz="1400"/>
+              <a:t>both t</a:t>
+            </a:r>
+            <a:r>
+              <a:rPr sz="1400"/>
+              <a:t>he SOAP Anagrafe service and the REST Farmacia service, </a:t>
+            </a:r>
+            <a:r>
+              <a:rPr lang="it-IT" sz="1400"/>
+              <a:t>unifying</a:t>
+            </a:r>
+            <a:r>
+              <a:rPr lang="it-IT" sz="1400"/>
+              <a:t> </a:t>
+            </a:r>
+            <a:r>
+              <a:rPr sz="1400"/>
+              <a:t>the</a:t>
+            </a:r>
+            <a:r>
+              <a:rPr lang="it-IT" sz="1400"/>
+              <a:t>ir</a:t>
+            </a:r>
+            <a:r>
+              <a:rPr sz="1400"/>
+              <a:t> data and return</a:t>
+            </a:r>
+            <a:r>
+              <a:rPr lang="it-IT" sz="1400"/>
+              <a:t>ing</a:t>
+            </a:r>
+            <a:r>
+              <a:rPr sz="1400"/>
+              <a:t> a full Clinical Profile of the patient.</a:t>
+            </a:r>
+            <a:endParaRPr sz="1400"/>
+          </a:p>
+          <a:p>
+            <a:pPr marL="239821" indent="-239821">
+              <a:buFont typeface="Arial"/>
+              <a:buChar char="•"/>
+              <a:defRPr/>
+            </a:pPr>
+            <a:r>
+              <a:rPr sz="1400"/>
+              <a:t>At the very </a:t>
+            </a:r>
+            <a:r>
+              <a:rPr lang="it-IT" sz="1400"/>
+              <a:t>end</a:t>
+            </a:r>
+            <a:r>
+              <a:rPr sz="1400"/>
+              <a:t> we have the </a:t>
+            </a:r>
+            <a:r>
+              <a:rPr sz="1400" b="1"/>
+              <a:t>Care Coordinator</a:t>
+            </a:r>
+            <a:r>
+              <a:rPr lang="it-IT" sz="1400"/>
+              <a:t>, which</a:t>
+            </a:r>
+            <a:r>
+              <a:rPr sz="1400"/>
+              <a:t> is the main orchestrator of our platform. It calls both the Clinical and Diagnostic aggregators in parallel, it waits for both </a:t>
+            </a:r>
+            <a:r>
+              <a:rPr lang="it-IT" sz="1400"/>
+              <a:t>of them t</a:t>
+            </a:r>
+            <a:r>
+              <a:rPr sz="1400"/>
+              <a:t>o finish</a:t>
+            </a:r>
+            <a:r>
+              <a:rPr lang="it-IT" sz="1400"/>
+              <a:t> and then </a:t>
+            </a:r>
+            <a:r>
+              <a:rPr sz="1400"/>
+              <a:t>cross-references all the data</a:t>
+            </a:r>
+            <a:r>
+              <a:rPr lang="it-IT" sz="1400"/>
+              <a:t> </a:t>
+            </a:r>
+            <a:r>
+              <a:rPr sz="1400"/>
+              <a:t>applies </a:t>
+            </a:r>
+            <a:r>
+              <a:rPr lang="it-IT" sz="1400"/>
+              <a:t>its own </a:t>
+            </a:r>
+            <a:r>
+              <a:rPr sz="1400"/>
+              <a:t>business rules to </a:t>
+            </a:r>
+            <a:r>
+              <a:rPr sz="1400"/>
+              <a:t>generate</a:t>
+            </a:r>
+            <a:r>
+              <a:rPr lang="it-IT" sz="1400"/>
+              <a:t> </a:t>
+            </a:r>
+            <a:r>
+              <a:rPr sz="1400"/>
+              <a:t>the final report.</a:t>
+            </a:r>
             <a:endParaRPr lang="en-US"/>
           </a:p>
         </p:txBody>
       </p:sp>
       <p:sp>
         <p:nvSpPr>
-          <p:cNvPr id="1014053192" name="Slide Number Placeholder 3"/>
+          <p:cNvPr id="201728757" name="Slide Number Placeholder 3"/>
           <p:cNvSpPr>
             <a:spLocks noGrp="1"/>
           </p:cNvSpPr>
@@ -2026,7 +2854,7 @@
       </p:grpSpPr>
       <p:sp>
         <p:nvSpPr>
-          <p:cNvPr id="1263609355" name="Shape 0"/>
+          <p:cNvPr id="2070417838" name="Shape 0"/>
           <p:cNvSpPr/>
           <p:nvPr/>
         </p:nvSpPr>
@@ -2056,7 +2884,7 @@
       </p:sp>
       <p:sp>
         <p:nvSpPr>
-          <p:cNvPr id="662459104" name="Text 1"/>
+          <p:cNvPr id="914044834" name="Text 1"/>
           <p:cNvSpPr/>
           <p:nvPr/>
         </p:nvSpPr>
@@ -2096,7 +2924,7 @@
       </p:sp>
       <p:sp>
         <p:nvSpPr>
-          <p:cNvPr id="988031572" name="Text 2"/>
+          <p:cNvPr id="1999010290" name="Text 2"/>
           <p:cNvSpPr/>
           <p:nvPr/>
         </p:nvSpPr>
@@ -2154,7 +2982,7 @@
       </p:sp>
       <p:sp>
         <p:nvSpPr>
-          <p:cNvPr id="1912741677" name="Text 3"/>
+          <p:cNvPr id="1718697966" name="Text 3"/>
           <p:cNvSpPr/>
           <p:nvPr/>
         </p:nvSpPr>
@@ -2194,7 +3022,7 @@
       </p:sp>
       <p:sp>
         <p:nvSpPr>
-          <p:cNvPr id="1598873837" name="Text 4"/>
+          <p:cNvPr id="213551221" name="Text 4"/>
           <p:cNvSpPr/>
           <p:nvPr/>
         </p:nvSpPr>
@@ -2274,7 +3102,7 @@
       </p:grpSpPr>
       <p:sp>
         <p:nvSpPr>
-          <p:cNvPr id="1588246309" name="Text 0"/>
+          <p:cNvPr id="1398045218" name="Text 0"/>
           <p:cNvSpPr/>
           <p:nvPr/>
         </p:nvSpPr>
@@ -2314,7 +3142,7 @@
       </p:sp>
       <p:sp>
         <p:nvSpPr>
-          <p:cNvPr id="1824875483" name="Shape 1"/>
+          <p:cNvPr id="528561758" name="Shape 1"/>
           <p:cNvSpPr/>
           <p:nvPr/>
         </p:nvSpPr>
@@ -2344,7 +3172,7 @@
       </p:sp>
       <p:sp>
         <p:nvSpPr>
-          <p:cNvPr id="232659384" name="Shape 2"/>
+          <p:cNvPr id="672568622" name="Shape 2"/>
           <p:cNvSpPr/>
           <p:nvPr/>
         </p:nvSpPr>
@@ -2379,7 +3207,7 @@
       </p:sp>
       <p:sp>
         <p:nvSpPr>
-          <p:cNvPr id="1729682513" name="Text 3"/>
+          <p:cNvPr id="899474782" name="Text 3"/>
           <p:cNvSpPr/>
           <p:nvPr/>
         </p:nvSpPr>
@@ -2419,7 +3247,7 @@
       </p:sp>
       <p:sp>
         <p:nvSpPr>
-          <p:cNvPr id="34955336" name="Text 4"/>
+          <p:cNvPr id="1179412029" name="Text 4"/>
           <p:cNvSpPr/>
           <p:nvPr/>
         </p:nvSpPr>
@@ -2459,7 +3287,7 @@
       </p:sp>
       <p:sp>
         <p:nvSpPr>
-          <p:cNvPr id="550678214" name="Text 5"/>
+          <p:cNvPr id="1616332113" name="Text 5"/>
           <p:cNvSpPr/>
           <p:nvPr/>
         </p:nvSpPr>
@@ -2664,7 +3492,7 @@
       </p:sp>
       <p:sp>
         <p:nvSpPr>
-          <p:cNvPr id="187787055" name="Text 6"/>
+          <p:cNvPr id="1198445622" name="Text 6"/>
           <p:cNvSpPr/>
           <p:nvPr/>
         </p:nvSpPr>
@@ -2704,7 +3532,7 @@
       </p:sp>
       <p:sp>
         <p:nvSpPr>
-          <p:cNvPr id="749895548" name="Text 7"/>
+          <p:cNvPr id="982274871" name="Text 7"/>
           <p:cNvSpPr/>
           <p:nvPr/>
         </p:nvSpPr>
@@ -2799,7 +3627,7 @@
       </p:sp>
       <p:sp>
         <p:nvSpPr>
-          <p:cNvPr id="1936635098" name="Text 8"/>
+          <p:cNvPr id="1804010435" name="Text 8"/>
           <p:cNvSpPr/>
           <p:nvPr/>
         </p:nvSpPr>
@@ -2839,7 +3667,7 @@
       </p:sp>
       <p:sp>
         <p:nvSpPr>
-          <p:cNvPr id="827034460" name="Text 9"/>
+          <p:cNvPr id="1876287052" name="Text 9"/>
           <p:cNvSpPr/>
           <p:nvPr/>
         </p:nvSpPr>
@@ -2912,7 +3740,7 @@
       </p:sp>
       <p:sp>
         <p:nvSpPr>
-          <p:cNvPr id="481102714" name="Text 10"/>
+          <p:cNvPr id="1800540494" name="Text 10"/>
           <p:cNvSpPr/>
           <p:nvPr/>
         </p:nvSpPr>
@@ -2952,7 +3780,7 @@
       </p:sp>
       <p:sp>
         <p:nvSpPr>
-          <p:cNvPr id="1121331854" name="Text 11"/>
+          <p:cNvPr id="970207017" name="Text 11"/>
           <p:cNvSpPr/>
           <p:nvPr/>
         </p:nvSpPr>
@@ -3102,7 +3930,7 @@
       </p:sp>
       <p:sp>
         <p:nvSpPr>
-          <p:cNvPr id="1412929629" name="Text 12"/>
+          <p:cNvPr id="984372768" name="Text 12"/>
           <p:cNvSpPr/>
           <p:nvPr/>
         </p:nvSpPr>
@@ -3164,7 +3992,7 @@
       </p:sp>
       <p:sp>
         <p:nvSpPr>
-          <p:cNvPr id="857153640" name="Text 13"/>
+          <p:cNvPr id="1047005773" name="Text 13"/>
           <p:cNvSpPr/>
           <p:nvPr/>
         </p:nvSpPr>
@@ -3344,7 +4172,7 @@
       </p:sp>
       <p:sp>
         <p:nvSpPr>
-          <p:cNvPr id="1073115331" name="Text 14"/>
+          <p:cNvPr id="2101665279" name="Text 14"/>
           <p:cNvSpPr/>
           <p:nvPr/>
         </p:nvSpPr>
@@ -3384,7 +4212,7 @@
       </p:sp>
       <p:sp>
         <p:nvSpPr>
-          <p:cNvPr id="1600018877" name="Text 15"/>
+          <p:cNvPr id="898521247" name="Text 15"/>
           <p:cNvSpPr/>
           <p:nvPr/>
         </p:nvSpPr>
@@ -3512,7 +4340,7 @@
       </p:sp>
       <p:sp>
         <p:nvSpPr>
-          <p:cNvPr id="1272750507" name="Text 16"/>
+          <p:cNvPr id="1310731210" name="Text 16"/>
           <p:cNvSpPr/>
           <p:nvPr/>
         </p:nvSpPr>
@@ -3574,7 +4402,7 @@
       </p:sp>
       <p:sp>
         <p:nvSpPr>
-          <p:cNvPr id="1749162605" name="Text 17"/>
+          <p:cNvPr id="1312369041" name="Text 17"/>
           <p:cNvSpPr/>
           <p:nvPr/>
         </p:nvSpPr>
@@ -3768,7 +4596,7 @@
       </p:sp>
       <p:sp>
         <p:nvSpPr>
-          <p:cNvPr id="219959867" name="Shape 18"/>
+          <p:cNvPr id="82846198" name="Shape 18"/>
           <p:cNvSpPr/>
           <p:nvPr/>
         </p:nvSpPr>
@@ -3803,7 +4631,7 @@
       </p:sp>
       <p:sp>
         <p:nvSpPr>
-          <p:cNvPr id="1063126096" name="Text 19"/>
+          <p:cNvPr id="114130720" name="Text 19"/>
           <p:cNvSpPr/>
           <p:nvPr/>
         </p:nvSpPr>
@@ -3843,7 +4671,7 @@
       </p:sp>
       <p:sp>
         <p:nvSpPr>
-          <p:cNvPr id="692715945" name="Text 20"/>
+          <p:cNvPr id="2094211923" name="Text 20"/>
           <p:cNvSpPr/>
           <p:nvPr/>
         </p:nvSpPr>
@@ -3905,7 +4733,7 @@
       </p:sp>
       <p:sp>
         <p:nvSpPr>
-          <p:cNvPr id="1066592790" name="Text 21"/>
+          <p:cNvPr id="2136243752" name="Text 21"/>
           <p:cNvSpPr/>
           <p:nvPr/>
         </p:nvSpPr>
@@ -4011,13 +4839,13 @@
       </p:sp>
       <p:sp>
         <p:nvSpPr>
-          <p:cNvPr id="2079416436" name="Text 22"/>
-          <p:cNvSpPr/>
-          <p:nvPr/>
-        </p:nvSpPr>
-        <p:spPr bwMode="auto">
-          <a:xfrm>
-            <a:off x="4937760" y="2551174"/>
+          <p:cNvPr id="1364632384" name="Text 22"/>
+          <p:cNvSpPr/>
+          <p:nvPr/>
+        </p:nvSpPr>
+        <p:spPr bwMode="auto">
+          <a:xfrm>
+            <a:off x="4937760" y="2551173"/>
             <a:ext cx="1417320" cy="256032"/>
           </a:xfrm>
           <a:prstGeom prst="rect">
@@ -4073,7 +4901,7 @@
       </p:sp>
       <p:sp>
         <p:nvSpPr>
-          <p:cNvPr id="1978049385" name="Text 23"/>
+          <p:cNvPr id="573045302" name="Text 23"/>
           <p:cNvSpPr/>
           <p:nvPr/>
         </p:nvSpPr>
@@ -4245,7 +5073,7 @@
       </p:sp>
       <p:sp>
         <p:nvSpPr>
-          <p:cNvPr id="1843961760" name="Text 24"/>
+          <p:cNvPr id="1593153168" name="Text 24"/>
           <p:cNvSpPr/>
           <p:nvPr/>
         </p:nvSpPr>
@@ -4307,7 +5135,7 @@
       </p:sp>
       <p:sp>
         <p:nvSpPr>
-          <p:cNvPr id="1094088269" name="Text 25"/>
+          <p:cNvPr id="1009765390" name="Text 25"/>
           <p:cNvSpPr/>
           <p:nvPr/>
         </p:nvSpPr>
@@ -4472,7 +5300,7 @@
       </p:sp>
       <p:sp>
         <p:nvSpPr>
-          <p:cNvPr id="1474400512" name="Text 26"/>
+          <p:cNvPr id="1139423510" name="Text 26"/>
           <p:cNvSpPr/>
           <p:nvPr/>
         </p:nvSpPr>
@@ -4534,7 +5362,7 @@
       </p:sp>
       <p:sp>
         <p:nvSpPr>
-          <p:cNvPr id="678084511" name="Text 27"/>
+          <p:cNvPr id="263103992" name="Text 27"/>
           <p:cNvSpPr/>
           <p:nvPr/>
         </p:nvSpPr>
@@ -4896,7 +5724,7 @@
       </p:grpSpPr>
       <p:sp>
         <p:nvSpPr>
-          <p:cNvPr id="2055134899" name="Text 0"/>
+          <p:cNvPr id="1562884865" name="Text 0"/>
           <p:cNvSpPr/>
           <p:nvPr/>
         </p:nvSpPr>
@@ -4958,7 +5786,7 @@
       </p:sp>
       <p:sp>
         <p:nvSpPr>
-          <p:cNvPr id="1869229557" name="Text 1"/>
+          <p:cNvPr id="2011369957" name="Text 1"/>
           <p:cNvSpPr/>
           <p:nvPr/>
         </p:nvSpPr>
@@ -4987,7 +5815,7 @@
       </p:sp>
       <p:sp>
         <p:nvSpPr>
-          <p:cNvPr id="933419180" name="Text 2"/>
+          <p:cNvPr id="354141629" name="Text 2"/>
           <p:cNvSpPr/>
           <p:nvPr/>
         </p:nvSpPr>
@@ -5016,7 +5844,7 @@
       </p:sp>
       <p:sp>
         <p:nvSpPr>
-          <p:cNvPr id="2048996188" name="Text 1"/>
+          <p:cNvPr id="979448960" name="Text 1"/>
           <p:cNvSpPr/>
           <p:nvPr/>
         </p:nvSpPr>
@@ -5096,7 +5924,7 @@
       </p:grpSpPr>
       <p:sp>
         <p:nvSpPr>
-          <p:cNvPr id="1056757296" name="Text 0"/>
+          <p:cNvPr id="441270449" name="Text 0"/>
           <p:cNvSpPr/>
           <p:nvPr/>
         </p:nvSpPr>
@@ -5136,7 +5964,7 @@
       </p:sp>
       <p:sp>
         <p:nvSpPr>
-          <p:cNvPr id="1195601032" name="Shape 1"/>
+          <p:cNvPr id="239086865" name="Shape 1"/>
           <p:cNvSpPr/>
           <p:nvPr/>
         </p:nvSpPr>
@@ -5166,7 +5994,7 @@
       </p:sp>
       <p:sp>
         <p:nvSpPr>
-          <p:cNvPr id="623881914" name="Shape 2"/>
+          <p:cNvPr id="1943988369" name="Shape 2"/>
           <p:cNvSpPr/>
           <p:nvPr/>
         </p:nvSpPr>
@@ -5201,7 +6029,7 @@
       </p:sp>
       <p:sp>
         <p:nvSpPr>
-          <p:cNvPr id="20248635" name="Text 3"/>
+          <p:cNvPr id="211753355" name="Text 3"/>
           <p:cNvSpPr/>
           <p:nvPr/>
         </p:nvSpPr>
@@ -5241,7 +6069,7 @@
       </p:sp>
       <p:sp>
         <p:nvSpPr>
-          <p:cNvPr id="1120712151" name="Shape 4"/>
+          <p:cNvPr id="743039172" name="Shape 4"/>
           <p:cNvSpPr/>
           <p:nvPr/>
         </p:nvSpPr>
@@ -5276,7 +6104,7 @@
       </p:sp>
       <p:sp>
         <p:nvSpPr>
-          <p:cNvPr id="1729867459" name="Text 5"/>
+          <p:cNvPr id="1836545836" name="Text 5"/>
           <p:cNvSpPr/>
           <p:nvPr/>
         </p:nvSpPr>
@@ -5316,7 +6144,7 @@
       </p:sp>
       <p:sp>
         <p:nvSpPr>
-          <p:cNvPr id="1236913493" name="Shape 6"/>
+          <p:cNvPr id="1556289881" name="Shape 6"/>
           <p:cNvSpPr/>
           <p:nvPr/>
         </p:nvSpPr>
@@ -5351,7 +6179,7 @@
       </p:sp>
       <p:sp>
         <p:nvSpPr>
-          <p:cNvPr id="953098044" name="Text 7"/>
+          <p:cNvPr id="910579087" name="Text 7"/>
           <p:cNvSpPr/>
           <p:nvPr/>
         </p:nvSpPr>
@@ -5391,7 +6219,7 @@
       </p:sp>
       <p:sp>
         <p:nvSpPr>
-          <p:cNvPr id="1599030380" name="Shape 8"/>
+          <p:cNvPr id="1966812803" name="Shape 8"/>
           <p:cNvSpPr/>
           <p:nvPr/>
         </p:nvSpPr>
@@ -5426,7 +6254,7 @@
       </p:sp>
       <p:sp>
         <p:nvSpPr>
-          <p:cNvPr id="976743476" name="Text 9"/>
+          <p:cNvPr id="330468040" name="Text 9"/>
           <p:cNvSpPr/>
           <p:nvPr/>
         </p:nvSpPr>
@@ -5466,7 +6294,7 @@
       </p:sp>
       <p:sp>
         <p:nvSpPr>
-          <p:cNvPr id="646209530" name="Shape 10"/>
+          <p:cNvPr id="757610092" name="Shape 10"/>
           <p:cNvSpPr/>
           <p:nvPr/>
         </p:nvSpPr>
@@ -5501,7 +6329,7 @@
       </p:sp>
       <p:sp>
         <p:nvSpPr>
-          <p:cNvPr id="444883570" name="Text 11"/>
+          <p:cNvPr id="854248781" name="Text 11"/>
           <p:cNvSpPr/>
           <p:nvPr/>
         </p:nvSpPr>
@@ -5541,7 +6369,7 @@
       </p:sp>
       <p:sp>
         <p:nvSpPr>
-          <p:cNvPr id="539506443" name="Shape 12"/>
+          <p:cNvPr id="732765097" name="Shape 12"/>
           <p:cNvSpPr/>
           <p:nvPr/>
         </p:nvSpPr>
@@ -5576,7 +6404,7 @@
       </p:sp>
       <p:sp>
         <p:nvSpPr>
-          <p:cNvPr id="913983652" name="Text 13"/>
+          <p:cNvPr id="1022694411" name="Text 13"/>
           <p:cNvSpPr/>
           <p:nvPr/>
         </p:nvSpPr>
@@ -5634,7 +6462,7 @@
       </p:sp>
       <p:sp>
         <p:nvSpPr>
-          <p:cNvPr id="2127979057" name="Shape 14"/>
+          <p:cNvPr id="1433185698" name="Shape 14"/>
           <p:cNvSpPr/>
           <p:nvPr/>
         </p:nvSpPr>
@@ -5669,7 +6497,7 @@
       </p:sp>
       <p:sp>
         <p:nvSpPr>
-          <p:cNvPr id="1698662191" name="Text 15"/>
+          <p:cNvPr id="1301922626" name="Text 15"/>
           <p:cNvSpPr/>
           <p:nvPr/>
         </p:nvSpPr>
@@ -5727,7 +6555,7 @@
       </p:sp>
       <p:sp>
         <p:nvSpPr>
-          <p:cNvPr id="947104760" name="Shape 16"/>
+          <p:cNvPr id="600438132" name="Shape 16"/>
           <p:cNvSpPr/>
           <p:nvPr/>
         </p:nvSpPr>
@@ -5762,7 +6590,7 @@
       </p:sp>
       <p:sp>
         <p:nvSpPr>
-          <p:cNvPr id="1829544700" name="Text 17"/>
+          <p:cNvPr id="976313300" name="Text 17"/>
           <p:cNvSpPr/>
           <p:nvPr/>
         </p:nvSpPr>
@@ -5820,7 +6648,7 @@
       </p:sp>
       <p:sp>
         <p:nvSpPr>
-          <p:cNvPr id="1801666776" name="Shape 18"/>
+          <p:cNvPr id="541108036" name="Shape 18"/>
           <p:cNvSpPr/>
           <p:nvPr/>
         </p:nvSpPr>
@@ -5855,7 +6683,7 @@
       </p:sp>
       <p:sp>
         <p:nvSpPr>
-          <p:cNvPr id="403445539" name="Text 19"/>
+          <p:cNvPr id="1644156800" name="Text 19"/>
           <p:cNvSpPr/>
           <p:nvPr/>
         </p:nvSpPr>
@@ -5895,7 +6723,7 @@
       </p:sp>
       <p:sp>
         <p:nvSpPr>
-          <p:cNvPr id="1194113241" name="Shape 20"/>
+          <p:cNvPr id="1614775461" name="Shape 20"/>
           <p:cNvSpPr/>
           <p:nvPr/>
         </p:nvSpPr>
@@ -5930,7 +6758,7 @@
       </p:sp>
       <p:sp>
         <p:nvSpPr>
-          <p:cNvPr id="219439261" name="Text 21"/>
+          <p:cNvPr id="642527269" name="Text 21"/>
           <p:cNvSpPr/>
           <p:nvPr/>
         </p:nvSpPr>
@@ -5988,7 +6816,7 @@
       </p:sp>
       <p:sp>
         <p:nvSpPr>
-          <p:cNvPr id="1291029697" name="Shape 22"/>
+          <p:cNvPr id="451656741" name="Shape 22"/>
           <p:cNvSpPr/>
           <p:nvPr/>
         </p:nvSpPr>
@@ -6023,7 +6851,7 @@
       </p:sp>
       <p:sp>
         <p:nvSpPr>
-          <p:cNvPr id="2052561001" name="Text 23"/>
+          <p:cNvPr id="898853599" name="Text 23"/>
           <p:cNvSpPr/>
           <p:nvPr/>
         </p:nvSpPr>
@@ -6081,7 +6909,7 @@
       </p:sp>
       <p:sp>
         <p:nvSpPr>
-          <p:cNvPr id="21751088" name="Shape 24"/>
+          <p:cNvPr id="1850147867" name="Shape 24"/>
           <p:cNvSpPr/>
           <p:nvPr/>
         </p:nvSpPr>
@@ -6116,7 +6944,7 @@
       </p:sp>
       <p:sp>
         <p:nvSpPr>
-          <p:cNvPr id="575292821" name="Text 25"/>
+          <p:cNvPr id="519393112" name="Text 25"/>
           <p:cNvSpPr/>
           <p:nvPr/>
         </p:nvSpPr>
@@ -6174,7 +7002,7 @@
       </p:sp>
       <p:sp>
         <p:nvSpPr>
-          <p:cNvPr id="1078358900" name="Shape 26"/>
+          <p:cNvPr id="786489560" name="Shape 26"/>
           <p:cNvSpPr/>
           <p:nvPr/>
         </p:nvSpPr>
@@ -6209,7 +7037,7 @@
       </p:sp>
       <p:sp>
         <p:nvSpPr>
-          <p:cNvPr id="1888473139" name="Text 27"/>
+          <p:cNvPr id="1275470612" name="Text 27"/>
           <p:cNvSpPr/>
           <p:nvPr/>
         </p:nvSpPr>
@@ -6249,7 +7077,7 @@
       </p:sp>
       <p:sp>
         <p:nvSpPr>
-          <p:cNvPr id="1179105899" name="Shape 28"/>
+          <p:cNvPr id="5613338" name="Shape 28"/>
           <p:cNvSpPr/>
           <p:nvPr/>
         </p:nvSpPr>
@@ -6284,7 +7112,7 @@
       </p:sp>
       <p:sp>
         <p:nvSpPr>
-          <p:cNvPr id="458685782" name="Text 29"/>
+          <p:cNvPr id="2093359866" name="Text 29"/>
           <p:cNvSpPr/>
           <p:nvPr/>
         </p:nvSpPr>
@@ -6342,7 +7170,7 @@
       </p:sp>
       <p:sp>
         <p:nvSpPr>
-          <p:cNvPr id="1664567122" name="Shape 30"/>
+          <p:cNvPr id="1365823250" name="Shape 30"/>
           <p:cNvSpPr/>
           <p:nvPr/>
         </p:nvSpPr>
@@ -6377,7 +7205,7 @@
       </p:sp>
       <p:sp>
         <p:nvSpPr>
-          <p:cNvPr id="1109717894" name="Text 31"/>
+          <p:cNvPr id="1209187585" name="Text 31"/>
           <p:cNvSpPr/>
           <p:nvPr/>
         </p:nvSpPr>
@@ -6435,7 +7263,7 @@
       </p:sp>
       <p:sp>
         <p:nvSpPr>
-          <p:cNvPr id="1921411719" name="Shape 32"/>
+          <p:cNvPr id="1187795662" name="Shape 32"/>
           <p:cNvSpPr/>
           <p:nvPr/>
         </p:nvSpPr>
@@ -6470,7 +7298,7 @@
       </p:sp>
       <p:sp>
         <p:nvSpPr>
-          <p:cNvPr id="1731122928" name="Text 33"/>
+          <p:cNvPr id="111568521" name="Text 33"/>
           <p:cNvSpPr/>
           <p:nvPr/>
         </p:nvSpPr>
@@ -6528,7 +7356,7 @@
       </p:sp>
       <p:sp>
         <p:nvSpPr>
-          <p:cNvPr id="997138386" name="Shape 34"/>
+          <p:cNvPr id="2142760624" name="Shape 34"/>
           <p:cNvSpPr/>
           <p:nvPr/>
         </p:nvSpPr>
@@ -6563,7 +7391,7 @@
       </p:sp>
       <p:sp>
         <p:nvSpPr>
-          <p:cNvPr id="899753875" name="Text 35"/>
+          <p:cNvPr id="469353674" name="Text 35"/>
           <p:cNvSpPr/>
           <p:nvPr/>
         </p:nvSpPr>
@@ -6603,7 +7431,7 @@
       </p:sp>
       <p:sp>
         <p:nvSpPr>
-          <p:cNvPr id="1161603452" name="Shape 36"/>
+          <p:cNvPr id="1322996023" name="Shape 36"/>
           <p:cNvSpPr/>
           <p:nvPr/>
         </p:nvSpPr>
@@ -6638,7 +7466,7 @@
       </p:sp>
       <p:sp>
         <p:nvSpPr>
-          <p:cNvPr id="120198860" name="Text 37"/>
+          <p:cNvPr id="1845894158" name="Text 37"/>
           <p:cNvSpPr/>
           <p:nvPr/>
         </p:nvSpPr>
@@ -6696,7 +7524,7 @@
       </p:sp>
       <p:sp>
         <p:nvSpPr>
-          <p:cNvPr id="293646157" name="Shape 38"/>
+          <p:cNvPr id="113395887" name="Shape 38"/>
           <p:cNvSpPr/>
           <p:nvPr/>
         </p:nvSpPr>
@@ -6731,7 +7559,7 @@
       </p:sp>
       <p:sp>
         <p:nvSpPr>
-          <p:cNvPr id="1918160903" name="Text 39"/>
+          <p:cNvPr id="1887708606" name="Text 39"/>
           <p:cNvSpPr/>
           <p:nvPr/>
         </p:nvSpPr>
@@ -6789,7 +7617,7 @@
       </p:sp>
       <p:sp>
         <p:nvSpPr>
-          <p:cNvPr id="1212730521" name="Shape 40"/>
+          <p:cNvPr id="1204647646" name="Shape 40"/>
           <p:cNvSpPr/>
           <p:nvPr/>
         </p:nvSpPr>
@@ -6824,7 +7652,7 @@
       </p:sp>
       <p:sp>
         <p:nvSpPr>
-          <p:cNvPr id="992854883" name="Text 41"/>
+          <p:cNvPr id="221381015" name="Text 41"/>
           <p:cNvSpPr/>
           <p:nvPr/>
         </p:nvSpPr>
@@ -6915,7 +7743,7 @@
       </p:grpSpPr>
       <p:sp>
         <p:nvSpPr>
-          <p:cNvPr id="1302682028" name="Title"/>
+          <p:cNvPr id="1397286025" name="Title"/>
           <p:cNvSpPr/>
           <p:nvPr/>
         </p:nvSpPr>
@@ -6955,7 +7783,7 @@
       </p:sp>
       <p:sp>
         <p:nvSpPr>
-          <p:cNvPr id="1601214952" name="ScenCard"/>
+          <p:cNvPr id="1421835661" name="ScenCard"/>
           <p:cNvSpPr/>
           <p:nvPr/>
         </p:nvSpPr>
@@ -7047,7 +7875,7 @@
       </p:sp>
       <p:sp>
         <p:nvSpPr>
-          <p:cNvPr id="909134023" name="Bar201"/>
+          <p:cNvPr id="1930392493" name="Bar201"/>
           <p:cNvSpPr/>
           <p:nvPr/>
         </p:nvSpPr>
@@ -7077,7 +7905,7 @@
       </p:sp>
       <p:sp>
         <p:nvSpPr>
-          <p:cNvPr id="1409818390" name="Badge210"/>
+          <p:cNvPr id="129233469" name="Badge210"/>
           <p:cNvSpPr/>
           <p:nvPr/>
         </p:nvSpPr>
@@ -7119,7 +7947,7 @@
       </p:sp>
       <p:sp>
         <p:nvSpPr>
-          <p:cNvPr id="1412116955" name="Badge211"/>
+          <p:cNvPr id="1366409342" name="Badge211"/>
           <p:cNvSpPr/>
           <p:nvPr/>
         </p:nvSpPr>
@@ -7161,7 +7989,7 @@
       </p:sp>
       <p:sp>
         <p:nvSpPr>
-          <p:cNvPr id="585601824" name="Badge212"/>
+          <p:cNvPr id="1214170491" name="Badge212"/>
           <p:cNvSpPr/>
           <p:nvPr/>
         </p:nvSpPr>
@@ -7203,7 +8031,7 @@
       </p:sp>
       <p:sp>
         <p:nvSpPr>
-          <p:cNvPr id="1320170426" name="RepLbl"/>
+          <p:cNvPr id="413471440" name="RepLbl"/>
           <p:cNvSpPr/>
           <p:nvPr/>
         </p:nvSpPr>
@@ -7247,7 +8075,7 @@
       </p:sp>
       <p:sp>
         <p:nvSpPr>
-          <p:cNvPr id="1955280604" name="Bar300"/>
+          <p:cNvPr id="1467829419" name="Bar300"/>
           <p:cNvSpPr/>
           <p:nvPr/>
         </p:nvSpPr>
@@ -7277,7 +8105,7 @@
       </p:sp>
       <p:sp>
         <p:nvSpPr>
-          <p:cNvPr id="960472641" name="Item0"/>
+          <p:cNvPr id="971415296" name="Item0"/>
           <p:cNvSpPr/>
           <p:nvPr/>
         </p:nvSpPr>
@@ -7330,7 +8158,7 @@
       </p:sp>
       <p:sp>
         <p:nvSpPr>
-          <p:cNvPr id="620022881" name="Bar310"/>
+          <p:cNvPr id="1359186866" name="Bar310"/>
           <p:cNvSpPr/>
           <p:nvPr/>
         </p:nvSpPr>
@@ -7360,7 +8188,7 @@
       </p:sp>
       <p:sp>
         <p:nvSpPr>
-          <p:cNvPr id="1723564729" name="Item1"/>
+          <p:cNvPr id="1270941768" name="Item1"/>
           <p:cNvSpPr/>
           <p:nvPr/>
         </p:nvSpPr>
@@ -7413,7 +8241,7 @@
       </p:sp>
       <p:sp>
         <p:nvSpPr>
-          <p:cNvPr id="1141761693" name="Bar320"/>
+          <p:cNvPr id="450975496" name="Bar320"/>
           <p:cNvSpPr/>
           <p:nvPr/>
         </p:nvSpPr>
@@ -7443,7 +8271,7 @@
       </p:sp>
       <p:sp>
         <p:nvSpPr>
-          <p:cNvPr id="1664611480" name="Item2"/>
+          <p:cNvPr id="1209902861" name="Item2"/>
           <p:cNvSpPr/>
           <p:nvPr/>
         </p:nvSpPr>
@@ -7496,7 +8324,7 @@
       </p:sp>
       <p:sp>
         <p:nvSpPr>
-          <p:cNvPr id="829461806" name="Bar330"/>
+          <p:cNvPr id="1988246180" name="Bar330"/>
           <p:cNvSpPr/>
           <p:nvPr/>
         </p:nvSpPr>
@@ -7526,7 +8354,7 @@
       </p:sp>
       <p:sp>
         <p:nvSpPr>
-          <p:cNvPr id="1132983962" name="Item3"/>
+          <p:cNvPr id="418514895" name="Item3"/>
           <p:cNvSpPr/>
           <p:nvPr/>
         </p:nvSpPr>
@@ -7579,7 +8407,7 @@
       </p:sp>
       <p:sp>
         <p:nvSpPr>
-          <p:cNvPr id="1269621806" name="Bar340"/>
+          <p:cNvPr id="1549000662" name="Bar340"/>
           <p:cNvSpPr/>
           <p:nvPr/>
         </p:nvSpPr>
@@ -7609,7 +8437,7 @@
       </p:sp>
       <p:sp>
         <p:nvSpPr>
-          <p:cNvPr id="668685023" name="Item4"/>
+          <p:cNvPr id="1310319022" name="Item4"/>
           <p:cNvSpPr/>
           <p:nvPr/>
         </p:nvSpPr>
@@ -7662,7 +8490,7 @@
       </p:sp>
       <p:sp>
         <p:nvSpPr>
-          <p:cNvPr id="1142343804" name="Bar350"/>
+          <p:cNvPr id="1489279917" name="Bar350"/>
           <p:cNvSpPr/>
           <p:nvPr/>
         </p:nvSpPr>
@@ -7692,7 +8520,7 @@
       </p:sp>
       <p:sp>
         <p:nvSpPr>
-          <p:cNvPr id="1019337209" name="Item5"/>
+          <p:cNvPr id="1242335510" name="Item5"/>
           <p:cNvSpPr/>
           <p:nvPr/>
         </p:nvSpPr>
@@ -7745,7 +8573,7 @@
       </p:sp>
       <p:sp>
         <p:nvSpPr>
-          <p:cNvPr id="594397559" name="Bar360"/>
+          <p:cNvPr id="836103717" name="Bar360"/>
           <p:cNvSpPr/>
           <p:nvPr/>
         </p:nvSpPr>
@@ -7775,7 +8603,7 @@
       </p:sp>
       <p:sp>
         <p:nvSpPr>
-          <p:cNvPr id="1138464183" name="Item6"/>
+          <p:cNvPr id="1364946491" name="Item6"/>
           <p:cNvSpPr/>
           <p:nvPr/>
         </p:nvSpPr>
@@ -7828,7 +8656,7 @@
       </p:sp>
       <p:sp>
         <p:nvSpPr>
-          <p:cNvPr id="1834196050" name="Bar370"/>
+          <p:cNvPr id="1246057316" name="Bar370"/>
           <p:cNvSpPr/>
           <p:nvPr/>
         </p:nvSpPr>
@@ -7858,7 +8686,7 @@
       </p:sp>
       <p:sp>
         <p:nvSpPr>
-          <p:cNvPr id="1794973188" name="Item7"/>
+          <p:cNvPr id="1227247808" name="Item7"/>
           <p:cNvSpPr/>
           <p:nvPr/>
         </p:nvSpPr>
@@ -7911,7 +8739,7 @@
       </p:sp>
       <p:sp>
         <p:nvSpPr>
-          <p:cNvPr id="1675361685" name="Shape 1"/>
+          <p:cNvPr id="476045766" name="Shape 1"/>
           <p:cNvSpPr/>
           <p:nvPr/>
         </p:nvSpPr>
@@ -7974,7 +8802,7 @@
       </p:grpSpPr>
       <p:sp>
         <p:nvSpPr>
-          <p:cNvPr id="1065360871" name="Title"/>
+          <p:cNvPr id="508822546" name="Title"/>
           <p:cNvSpPr/>
           <p:nvPr/>
         </p:nvSpPr>
@@ -8014,7 +8842,7 @@
       </p:sp>
       <p:sp>
         <p:nvSpPr>
-          <p:cNvPr id="738320584" name="Intro"/>
+          <p:cNvPr id="575728984" name="Intro"/>
           <p:cNvSpPr/>
           <p:nvPr/>
         </p:nvSpPr>
@@ -8074,7 +8902,7 @@
       </p:sp>
       <p:sp>
         <p:nvSpPr>
-          <p:cNvPr id="1246954513" name="Bar201"/>
+          <p:cNvPr id="1710733905" name="Bar201"/>
           <p:cNvSpPr/>
           <p:nvPr/>
         </p:nvSpPr>
@@ -8104,7 +8932,7 @@
       </p:sp>
       <p:sp>
         <p:nvSpPr>
-          <p:cNvPr id="2085487342" name="CPLbl"/>
+          <p:cNvPr id="1889445841" name="CPLbl"/>
           <p:cNvSpPr/>
           <p:nvPr/>
         </p:nvSpPr>
@@ -8148,7 +8976,7 @@
       </p:sp>
       <p:sp>
         <p:nvSpPr>
-          <p:cNvPr id="300396354" name="Bar220"/>
+          <p:cNvPr id="2123672444" name="Bar220"/>
           <p:cNvSpPr/>
           <p:nvPr/>
         </p:nvSpPr>
@@ -8178,7 +9006,7 @@
       </p:sp>
       <p:sp>
         <p:nvSpPr>
-          <p:cNvPr id="1038072732" name="CP0"/>
+          <p:cNvPr id="180780339" name="CP0"/>
           <p:cNvSpPr/>
           <p:nvPr/>
         </p:nvSpPr>
@@ -8249,7 +9077,7 @@
       </p:sp>
       <p:sp>
         <p:nvSpPr>
-          <p:cNvPr id="1606292326" name="Bar230"/>
+          <p:cNvPr id="462185069" name="Bar230"/>
           <p:cNvSpPr/>
           <p:nvPr/>
         </p:nvSpPr>
@@ -8279,7 +9107,7 @@
       </p:sp>
       <p:sp>
         <p:nvSpPr>
-          <p:cNvPr id="264389041" name="CP1"/>
+          <p:cNvPr id="1001300255" name="CP1"/>
           <p:cNvSpPr/>
           <p:nvPr/>
         </p:nvSpPr>
@@ -8368,7 +9196,7 @@
       </p:sp>
       <p:sp>
         <p:nvSpPr>
-          <p:cNvPr id="485187591" name="Bar240"/>
+          <p:cNvPr id="1286140208" name="Bar240"/>
           <p:cNvSpPr/>
           <p:nvPr/>
         </p:nvSpPr>
@@ -8398,7 +9226,7 @@
       </p:sp>
       <p:sp>
         <p:nvSpPr>
-          <p:cNvPr id="1417750489" name="CP2"/>
+          <p:cNvPr id="1375622928" name="CP2"/>
           <p:cNvSpPr/>
           <p:nvPr/>
         </p:nvSpPr>
@@ -8469,7 +9297,7 @@
       </p:sp>
       <p:sp>
         <p:nvSpPr>
-          <p:cNvPr id="266605900" name="Bar250"/>
+          <p:cNvPr id="1342651641" name="Bar250"/>
           <p:cNvSpPr/>
           <p:nvPr/>
         </p:nvSpPr>
@@ -8499,7 +9327,7 @@
       </p:sp>
       <p:sp>
         <p:nvSpPr>
-          <p:cNvPr id="1601281695" name="CP3"/>
+          <p:cNvPr id="481396400" name="CP3"/>
           <p:cNvSpPr/>
           <p:nvPr/>
         </p:nvSpPr>
@@ -8570,7 +9398,7 @@
       </p:sp>
       <p:sp>
         <p:nvSpPr>
-          <p:cNvPr id="521730879" name="AnaSource"/>
+          <p:cNvPr id="681690867" name="AnaSource"/>
           <p:cNvSpPr/>
           <p:nvPr/>
         </p:nvSpPr>
@@ -8655,7 +9483,7 @@
       </p:sp>
       <p:sp>
         <p:nvSpPr>
-          <p:cNvPr id="1929669236" name="Bar301"/>
+          <p:cNvPr id="4012424" name="Bar301"/>
           <p:cNvSpPr/>
           <p:nvPr/>
         </p:nvSpPr>
@@ -8685,7 +9513,7 @@
       </p:sp>
       <p:sp>
         <p:nvSpPr>
-          <p:cNvPr id="2047908432" name="FarmSource"/>
+          <p:cNvPr id="1749460551" name="FarmSource"/>
           <p:cNvSpPr/>
           <p:nvPr/>
         </p:nvSpPr>
@@ -8761,7 +9589,7 @@
       </p:sp>
       <p:sp>
         <p:nvSpPr>
-          <p:cNvPr id="130435541" name="Bar311"/>
+          <p:cNvPr id="1352972437" name="Bar311"/>
           <p:cNvSpPr/>
           <p:nvPr/>
         </p:nvSpPr>
@@ -8791,7 +9619,7 @@
       </p:sp>
       <p:sp>
         <p:nvSpPr>
-          <p:cNvPr id="663461844" name="Shape 1"/>
+          <p:cNvPr id="1695943537" name="Shape 1"/>
           <p:cNvSpPr/>
           <p:nvPr/>
         </p:nvSpPr>
@@ -8854,7 +9682,7 @@
       </p:grpSpPr>
       <p:sp>
         <p:nvSpPr>
-          <p:cNvPr id="2055621425" name="Title"/>
+          <p:cNvPr id="192533327" name="Title"/>
           <p:cNvSpPr/>
           <p:nvPr/>
         </p:nvSpPr>
@@ -8894,7 +9722,7 @@
       </p:sp>
       <p:sp>
         <p:nvSpPr>
-          <p:cNvPr id="1218914124" name="Badge200"/>
+          <p:cNvPr id="1562723977" name="Badge200"/>
           <p:cNvSpPr/>
           <p:nvPr/>
         </p:nvSpPr>
@@ -8936,7 +9764,7 @@
       </p:sp>
       <p:sp>
         <p:nvSpPr>
-          <p:cNvPr id="628674602" name="P1"/>
+          <p:cNvPr id="1543848608" name="P1"/>
           <p:cNvSpPr/>
           <p:nvPr/>
         </p:nvSpPr>
@@ -9044,7 +9872,7 @@
       </p:sp>
       <p:sp>
         <p:nvSpPr>
-          <p:cNvPr id="1778966857" name="Bar202"/>
+          <p:cNvPr id="1999305319" name="Bar202"/>
           <p:cNvSpPr/>
           <p:nvPr/>
         </p:nvSpPr>
@@ -9074,7 +9902,7 @@
       </p:sp>
       <p:sp>
         <p:nvSpPr>
-          <p:cNvPr id="1700498822" name="Badge210"/>
+          <p:cNvPr id="889416768" name="Badge210"/>
           <p:cNvSpPr/>
           <p:nvPr/>
         </p:nvSpPr>
@@ -9116,7 +9944,7 @@
       </p:sp>
       <p:sp>
         <p:nvSpPr>
-          <p:cNvPr id="372012440" name="P2"/>
+          <p:cNvPr id="809163280" name="P2"/>
           <p:cNvSpPr/>
           <p:nvPr/>
         </p:nvSpPr>
@@ -9240,7 +10068,7 @@
       </p:sp>
       <p:sp>
         <p:nvSpPr>
-          <p:cNvPr id="1670384765" name="Bar212"/>
+          <p:cNvPr id="1501742551" name="Bar212"/>
           <p:cNvSpPr/>
           <p:nvPr/>
         </p:nvSpPr>
@@ -9270,7 +10098,7 @@
       </p:sp>
       <p:sp>
         <p:nvSpPr>
-          <p:cNvPr id="958237866" name="Badge220"/>
+          <p:cNvPr id="1734907444" name="Badge220"/>
           <p:cNvSpPr/>
           <p:nvPr/>
         </p:nvSpPr>
@@ -9312,7 +10140,7 @@
       </p:sp>
       <p:sp>
         <p:nvSpPr>
-          <p:cNvPr id="1084611589" name="P3"/>
+          <p:cNvPr id="169018707" name="P3"/>
           <p:cNvSpPr/>
           <p:nvPr/>
         </p:nvSpPr>
@@ -9420,7 +10248,7 @@
       </p:sp>
       <p:sp>
         <p:nvSpPr>
-          <p:cNvPr id="33679111" name="Bar222"/>
+          <p:cNvPr id="1396611504" name="Bar222"/>
           <p:cNvSpPr/>
           <p:nvPr/>
         </p:nvSpPr>
@@ -9450,7 +10278,7 @@
       </p:sp>
       <p:sp>
         <p:nvSpPr>
-          <p:cNvPr id="1590939465" name="Shape 1"/>
+          <p:cNvPr id="1554537125" name="Shape 1"/>
           <p:cNvSpPr/>
           <p:nvPr/>
         </p:nvSpPr>
@@ -9513,7 +10341,7 @@
       </p:grpSpPr>
       <p:sp>
         <p:nvSpPr>
-          <p:cNvPr id="1228661166" name="Title"/>
+          <p:cNvPr id="177794633" name="Title"/>
           <p:cNvSpPr/>
           <p:nvPr/>
         </p:nvSpPr>
@@ -9553,7 +10381,7 @@
       </p:sp>
       <p:sp>
         <p:nvSpPr>
-          <p:cNvPr id="915457805" name="Sub"/>
+          <p:cNvPr id="595674928" name="Sub"/>
           <p:cNvSpPr/>
           <p:nvPr/>
         </p:nvSpPr>
@@ -9593,7 +10421,7 @@
       </p:sp>
       <p:sp>
         <p:nvSpPr>
-          <p:cNvPr id="77819215" name="Scenario"/>
+          <p:cNvPr id="1244323525" name="Scenario"/>
           <p:cNvSpPr/>
           <p:nvPr/>
         </p:nvSpPr>
@@ -9701,7 +10529,7 @@
       </p:sp>
       <p:sp>
         <p:nvSpPr>
-          <p:cNvPr id="1018449744" name="Bar201"/>
+          <p:cNvPr id="1231025550" name="Bar201"/>
           <p:cNvSpPr/>
           <p:nvPr/>
         </p:nvSpPr>
@@ -9731,7 +10559,7 @@
       </p:sp>
       <p:sp>
         <p:nvSpPr>
-          <p:cNvPr id="27570022" name="ReqLbl"/>
+          <p:cNvPr id="974394125" name="ReqLbl"/>
           <p:cNvSpPr/>
           <p:nvPr/>
         </p:nvSpPr>
@@ -9775,7 +10603,7 @@
       </p:sp>
       <p:sp>
         <p:nvSpPr>
-          <p:cNvPr id="922366890" name="Bar220"/>
+          <p:cNvPr id="1593882287" name="Bar220"/>
           <p:cNvSpPr/>
           <p:nvPr/>
         </p:nvSpPr>
@@ -9805,7 +10633,7 @@
       </p:sp>
       <p:sp>
         <p:nvSpPr>
-          <p:cNvPr id="100516816" name="Req0"/>
+          <p:cNvPr id="474702653" name="Req0"/>
           <p:cNvSpPr/>
           <p:nvPr/>
         </p:nvSpPr>
@@ -9876,7 +10704,7 @@
       </p:sp>
       <p:sp>
         <p:nvSpPr>
-          <p:cNvPr id="823073694" name="Bar230"/>
+          <p:cNvPr id="1759763204" name="Bar230"/>
           <p:cNvSpPr/>
           <p:nvPr/>
         </p:nvSpPr>
@@ -9906,7 +10734,7 @@
       </p:sp>
       <p:sp>
         <p:nvSpPr>
-          <p:cNvPr id="63770174" name="Req1"/>
+          <p:cNvPr id="197503896" name="Req1"/>
           <p:cNvSpPr/>
           <p:nvPr/>
         </p:nvSpPr>
@@ -9977,7 +10805,7 @@
       </p:sp>
       <p:sp>
         <p:nvSpPr>
-          <p:cNvPr id="1301970076" name="Bar240"/>
+          <p:cNvPr id="474446606" name="Bar240"/>
           <p:cNvSpPr/>
           <p:nvPr/>
         </p:nvSpPr>
@@ -10007,7 +10835,7 @@
       </p:sp>
       <p:sp>
         <p:nvSpPr>
-          <p:cNvPr id="2020376230" name="Req2"/>
+          <p:cNvPr id="1607304285" name="Req2"/>
           <p:cNvSpPr/>
           <p:nvPr/>
         </p:nvSpPr>
@@ -10078,7 +10906,7 @@
       </p:sp>
       <p:sp>
         <p:nvSpPr>
-          <p:cNvPr id="2136749983" name="Bar250"/>
+          <p:cNvPr id="334461986" name="Bar250"/>
           <p:cNvSpPr/>
           <p:nvPr/>
         </p:nvSpPr>
@@ -10108,7 +10936,7 @@
       </p:sp>
       <p:sp>
         <p:nvSpPr>
-          <p:cNvPr id="1521817228" name="Req3"/>
+          <p:cNvPr id="401150336" name="Req3"/>
           <p:cNvSpPr/>
           <p:nvPr/>
         </p:nvSpPr>
@@ -10179,7 +11007,7 @@
       </p:sp>
       <p:sp>
         <p:nvSpPr>
-          <p:cNvPr id="847706606" name="Bar260"/>
+          <p:cNvPr id="528733309" name="Bar260"/>
           <p:cNvSpPr/>
           <p:nvPr/>
         </p:nvSpPr>
@@ -10209,7 +11037,7 @@
       </p:sp>
       <p:sp>
         <p:nvSpPr>
-          <p:cNvPr id="751036182" name="Req4"/>
+          <p:cNvPr id="1696296807" name="Req4"/>
           <p:cNvSpPr/>
           <p:nvPr/>
         </p:nvSpPr>
@@ -10280,7 +11108,7 @@
       </p:sp>
       <p:sp>
         <p:nvSpPr>
-          <p:cNvPr id="886382587" name="ResLbl"/>
+          <p:cNvPr id="1913034046" name="ResLbl"/>
           <p:cNvSpPr/>
           <p:nvPr/>
         </p:nvSpPr>
@@ -10340,7 +11168,7 @@
       </p:sp>
       <p:sp>
         <p:nvSpPr>
-          <p:cNvPr id="1193256000" name="Bar271"/>
+          <p:cNvPr id="2046650576" name="Bar271"/>
           <p:cNvSpPr/>
           <p:nvPr/>
         </p:nvSpPr>
@@ -10370,7 +11198,7 @@
       </p:sp>
       <p:sp>
         <p:nvSpPr>
-          <p:cNvPr id="1443385099" name="Shape 1"/>
+          <p:cNvPr id="575193771" name="Shape 1"/>
           <p:cNvSpPr/>
           <p:nvPr/>
         </p:nvSpPr>
@@ -10440,7 +11268,7 @@
       </p:grpSpPr>
       <p:sp>
         <p:nvSpPr>
-          <p:cNvPr id="732129685" name="Text 0"/>
+          <p:cNvPr id="942902283" name="Text 0"/>
           <p:cNvSpPr/>
           <p:nvPr/>
         </p:nvSpPr>
@@ -10480,7 +11308,7 @@
       </p:sp>
       <p:sp>
         <p:nvSpPr>
-          <p:cNvPr id="803058277" name="Shape 1"/>
+          <p:cNvPr id="1576252707" name="Shape 1"/>
           <p:cNvSpPr/>
           <p:nvPr/>
         </p:nvSpPr>
@@ -10510,7 +11338,7 @@
       </p:sp>
       <p:sp>
         <p:nvSpPr>
-          <p:cNvPr id="885362309" name="Shape 2"/>
+          <p:cNvPr id="1444117341" name="Shape 2"/>
           <p:cNvSpPr/>
           <p:nvPr/>
         </p:nvSpPr>
@@ -10545,7 +11373,7 @@
       </p:sp>
       <p:sp>
         <p:nvSpPr>
-          <p:cNvPr id="565527624" name="Text 3"/>
+          <p:cNvPr id="1590158738" name="Text 3"/>
           <p:cNvSpPr/>
           <p:nvPr/>
         </p:nvSpPr>
@@ -10585,7 +11413,7 @@
       </p:sp>
       <p:sp>
         <p:nvSpPr>
-          <p:cNvPr id="750621232" name="Text 4"/>
+          <p:cNvPr id="2048938242" name="Text 4"/>
           <p:cNvSpPr/>
           <p:nvPr/>
         </p:nvSpPr>
@@ -10625,7 +11453,7 @@
       </p:sp>
       <p:sp>
         <p:nvSpPr>
-          <p:cNvPr id="1296734704" name="Text 5"/>
+          <p:cNvPr id="1879387966" name="Text 5"/>
           <p:cNvSpPr/>
           <p:nvPr/>
         </p:nvSpPr>
@@ -10665,7 +11493,7 @@
       </p:sp>
       <p:sp>
         <p:nvSpPr>
-          <p:cNvPr id="1080750099" name="Text 6"/>
+          <p:cNvPr id="881824758" name="Text 6"/>
           <p:cNvSpPr/>
           <p:nvPr/>
         </p:nvSpPr>
@@ -10705,7 +11533,7 @@
       </p:sp>
       <p:sp>
         <p:nvSpPr>
-          <p:cNvPr id="24431550" name="Text 7"/>
+          <p:cNvPr id="66031605" name="Text 7"/>
           <p:cNvSpPr/>
           <p:nvPr/>
         </p:nvSpPr>
@@ -10745,7 +11573,7 @@
       </p:sp>
       <p:sp>
         <p:nvSpPr>
-          <p:cNvPr id="1205950976" name="Text 8"/>
+          <p:cNvPr id="2110858569" name="Text 8"/>
           <p:cNvSpPr/>
           <p:nvPr/>
         </p:nvSpPr>
@@ -10785,7 +11613,7 @@
       </p:sp>
       <p:sp>
         <p:nvSpPr>
-          <p:cNvPr id="1847813204" name="Text 9"/>
+          <p:cNvPr id="1703333498" name="Text 9"/>
           <p:cNvSpPr/>
           <p:nvPr/>
         </p:nvSpPr>
@@ -10825,7 +11653,7 @@
       </p:sp>
       <p:sp>
         <p:nvSpPr>
-          <p:cNvPr id="1142090439" name="Text 10"/>
+          <p:cNvPr id="1643504856" name="Text 10"/>
           <p:cNvSpPr/>
           <p:nvPr/>
         </p:nvSpPr>
@@ -10865,7 +11693,7 @@
       </p:sp>
       <p:sp>
         <p:nvSpPr>
-          <p:cNvPr id="1473383431" name="Text 11"/>
+          <p:cNvPr id="304343089" name="Text 11"/>
           <p:cNvSpPr/>
           <p:nvPr/>
         </p:nvSpPr>
@@ -10927,7 +11755,7 @@
       </p:sp>
       <p:sp>
         <p:nvSpPr>
-          <p:cNvPr id="181993726" name="Text 12"/>
+          <p:cNvPr id="1849736477" name="Text 12"/>
           <p:cNvSpPr/>
           <p:nvPr/>
         </p:nvSpPr>
@@ -10967,7 +11795,7 @@
       </p:sp>
       <p:sp>
         <p:nvSpPr>
-          <p:cNvPr id="2022176471" name="Text 13"/>
+          <p:cNvPr id="2358694" name="Text 13"/>
           <p:cNvSpPr/>
           <p:nvPr/>
         </p:nvSpPr>
@@ -11007,7 +11835,7 @@
       </p:sp>
       <p:sp>
         <p:nvSpPr>
-          <p:cNvPr id="677287216" name="Text 14"/>
+          <p:cNvPr id="661138088" name="Text 14"/>
           <p:cNvSpPr/>
           <p:nvPr/>
         </p:nvSpPr>
@@ -11047,7 +11875,7 @@
       </p:sp>
       <p:sp>
         <p:nvSpPr>
-          <p:cNvPr id="317310610" name="Text 15"/>
+          <p:cNvPr id="1328220930" name="Text 15"/>
           <p:cNvSpPr/>
           <p:nvPr/>
         </p:nvSpPr>
@@ -11087,7 +11915,7 @@
       </p:sp>
       <p:sp>
         <p:nvSpPr>
-          <p:cNvPr id="1477969521" name="Text 16"/>
+          <p:cNvPr id="1591208370" name="Text 16"/>
           <p:cNvSpPr/>
           <p:nvPr/>
         </p:nvSpPr>
@@ -11127,7 +11955,7 @@
       </p:sp>
       <p:sp>
         <p:nvSpPr>
-          <p:cNvPr id="1977658205" name="Text 17"/>
+          <p:cNvPr id="2090644537" name="Text 17"/>
           <p:cNvSpPr/>
           <p:nvPr/>
         </p:nvSpPr>
@@ -11167,7 +11995,7 @@
       </p:sp>
       <p:sp>
         <p:nvSpPr>
-          <p:cNvPr id="589535997" name="Text 18"/>
+          <p:cNvPr id="1168628607" name="Text 18"/>
           <p:cNvSpPr/>
           <p:nvPr/>
         </p:nvSpPr>
@@ -11207,7 +12035,7 @@
       </p:sp>
       <p:sp>
         <p:nvSpPr>
-          <p:cNvPr id="553477625" name="Text 19"/>
+          <p:cNvPr id="1942331930" name="Text 19"/>
           <p:cNvSpPr/>
           <p:nvPr/>
         </p:nvSpPr>
@@ -11269,7 +12097,7 @@
       </p:sp>
       <p:sp>
         <p:nvSpPr>
-          <p:cNvPr id="969181286" name="Shape 20"/>
+          <p:cNvPr id="1302998145" name="Shape 20"/>
           <p:cNvSpPr/>
           <p:nvPr/>
         </p:nvSpPr>
@@ -11304,7 +12132,7 @@
       </p:sp>
       <p:sp>
         <p:nvSpPr>
-          <p:cNvPr id="1384428883" name="Text 21"/>
+          <p:cNvPr id="114568905" name="Text 21"/>
           <p:cNvSpPr/>
           <p:nvPr/>
         </p:nvSpPr>
@@ -11344,7 +12172,7 @@
       </p:sp>
       <p:sp>
         <p:nvSpPr>
-          <p:cNvPr id="408136883" name="Text 22"/>
+          <p:cNvPr id="574275712" name="Text 22"/>
           <p:cNvSpPr/>
           <p:nvPr/>
         </p:nvSpPr>
@@ -11384,7 +12212,7 @@
       </p:sp>
       <p:sp>
         <p:nvSpPr>
-          <p:cNvPr id="484841196" name="Text 23"/>
+          <p:cNvPr id="1838380879" name="Text 23"/>
           <p:cNvSpPr/>
           <p:nvPr/>
         </p:nvSpPr>
@@ -11424,7 +12252,7 @@
       </p:sp>
       <p:sp>
         <p:nvSpPr>
-          <p:cNvPr id="524191160" name="Text 24"/>
+          <p:cNvPr id="2088746885" name="Text 24"/>
           <p:cNvSpPr/>
           <p:nvPr/>
         </p:nvSpPr>
@@ -11464,7 +12292,7 @@
       </p:sp>
       <p:sp>
         <p:nvSpPr>
-          <p:cNvPr id="701382912" name="Text 25"/>
+          <p:cNvPr id="1631888377" name="Text 25"/>
           <p:cNvSpPr/>
           <p:nvPr/>
         </p:nvSpPr>
@@ -11504,7 +12332,7 @@
       </p:sp>
       <p:sp>
         <p:nvSpPr>
-          <p:cNvPr id="548564824" name="Text 26"/>
+          <p:cNvPr id="253916533" name="Text 26"/>
           <p:cNvSpPr/>
           <p:nvPr/>
         </p:nvSpPr>
@@ -11544,7 +12372,7 @@
       </p:sp>
       <p:sp>
         <p:nvSpPr>
-          <p:cNvPr id="770420087" name="Text 27"/>
+          <p:cNvPr id="2105186432" name="Text 27"/>
           <p:cNvSpPr/>
           <p:nvPr/>
         </p:nvSpPr>
@@ -11584,7 +12412,7 @@
       </p:sp>
       <p:sp>
         <p:nvSpPr>
-          <p:cNvPr id="91447575" name="Text 28"/>
+          <p:cNvPr id="1888621471" name="Text 28"/>
           <p:cNvSpPr/>
           <p:nvPr/>
         </p:nvSpPr>
@@ -11624,7 +12452,7 @@
       </p:sp>
       <p:sp>
         <p:nvSpPr>
-          <p:cNvPr id="620244370" name="Text 29"/>
+          <p:cNvPr id="1527153187" name="Text 29"/>
           <p:cNvSpPr/>
           <p:nvPr/>
         </p:nvSpPr>
@@ -11664,7 +12492,7 @@
       </p:sp>
       <p:sp>
         <p:nvSpPr>
-          <p:cNvPr id="583423648" name="Text 30"/>
+          <p:cNvPr id="406897330" name="Text 30"/>
           <p:cNvSpPr/>
           <p:nvPr/>
         </p:nvSpPr>
@@ -11704,7 +12532,7 @@
       </p:sp>
       <p:sp>
         <p:nvSpPr>
-          <p:cNvPr id="1065855262" name="Text 31"/>
+          <p:cNvPr id="80037235" name="Text 31"/>
           <p:cNvSpPr/>
           <p:nvPr/>
         </p:nvSpPr>
@@ -11744,7 +12572,7 @@
       </p:sp>
       <p:sp>
         <p:nvSpPr>
-          <p:cNvPr id="1989512319" name="Text 32"/>
+          <p:cNvPr id="573348028" name="Text 32"/>
           <p:cNvSpPr/>
           <p:nvPr/>
         </p:nvSpPr>
@@ -11784,7 +12612,7 @@
       </p:sp>
       <p:sp>
         <p:nvSpPr>
-          <p:cNvPr id="113178271" name="Text 33"/>
+          <p:cNvPr id="1746185146" name="Text 33"/>
           <p:cNvSpPr/>
           <p:nvPr/>
         </p:nvSpPr>
@@ -11824,7 +12652,7 @@
       </p:sp>
       <p:sp>
         <p:nvSpPr>
-          <p:cNvPr id="1179089663" name="Text 34"/>
+          <p:cNvPr id="210228818" name="Text 34"/>
           <p:cNvSpPr/>
           <p:nvPr/>
         </p:nvSpPr>
@@ -11864,7 +12692,7 @@
       </p:sp>
       <p:sp>
         <p:nvSpPr>
-          <p:cNvPr id="1518467148" name="Text 35"/>
+          <p:cNvPr id="127168271" name="Text 35"/>
           <p:cNvSpPr/>
           <p:nvPr/>
         </p:nvSpPr>
@@ -11904,7 +12732,7 @@
       </p:sp>
       <p:sp>
         <p:nvSpPr>
-          <p:cNvPr id="1228571991" name="Text 36"/>
+          <p:cNvPr id="1934151850" name="Text 36"/>
           <p:cNvSpPr/>
           <p:nvPr/>
         </p:nvSpPr>
@@ -11944,7 +12772,7 @@
       </p:sp>
       <p:sp>
         <p:nvSpPr>
-          <p:cNvPr id="1225883340" name="Text 37"/>
+          <p:cNvPr id="1217625303" name="Text 37"/>
           <p:cNvSpPr/>
           <p:nvPr/>
         </p:nvSpPr>
@@ -12024,7 +12852,7 @@
       </p:grpSpPr>
       <p:sp>
         <p:nvSpPr>
-          <p:cNvPr id="281577105" name="Text 0"/>
+          <p:cNvPr id="119730830" name="Text 0"/>
           <p:cNvSpPr/>
           <p:nvPr/>
         </p:nvSpPr>
@@ -12086,7 +12914,7 @@
       </p:sp>
       <p:sp>
         <p:nvSpPr>
-          <p:cNvPr id="487988286" name="Text 1"/>
+          <p:cNvPr id="107575423" name="Text 1"/>
           <p:cNvSpPr/>
           <p:nvPr/>
         </p:nvSpPr>
@@ -12126,7 +12954,7 @@
       </p:sp>
       <p:sp>
         <p:nvSpPr>
-          <p:cNvPr id="1634479877" name="Text 2"/>
+          <p:cNvPr id="63731328" name="Text 2"/>
           <p:cNvSpPr/>
           <p:nvPr/>
         </p:nvSpPr>
@@ -12206,7 +13034,7 @@
       </p:grpSpPr>
       <p:sp>
         <p:nvSpPr>
-          <p:cNvPr id="461394365" name="Text 0"/>
+          <p:cNvPr id="9820579" name="Text 0"/>
           <p:cNvSpPr/>
           <p:nvPr/>
         </p:nvSpPr>
@@ -12246,7 +13074,7 @@
       </p:sp>
       <p:sp>
         <p:nvSpPr>
-          <p:cNvPr id="1900350656" name="Shape 1"/>
+          <p:cNvPr id="95681206" name="Shape 1"/>
           <p:cNvSpPr/>
           <p:nvPr/>
         </p:nvSpPr>
@@ -12276,7 +13104,7 @@
       </p:sp>
       <p:sp>
         <p:nvSpPr>
-          <p:cNvPr id="1667755624" name="Shape 2"/>
+          <p:cNvPr id="730525047" name="Shape 2"/>
           <p:cNvSpPr/>
           <p:nvPr/>
         </p:nvSpPr>
@@ -12311,7 +13139,7 @@
       </p:sp>
       <p:sp>
         <p:nvSpPr>
-          <p:cNvPr id="1943028196" name="Shape 3"/>
+          <p:cNvPr id="682491536" name="Shape 3"/>
           <p:cNvSpPr/>
           <p:nvPr/>
         </p:nvSpPr>
@@ -12341,7 +13169,7 @@
       </p:sp>
       <p:sp>
         <p:nvSpPr>
-          <p:cNvPr id="485610850" name="Text 4"/>
+          <p:cNvPr id="812050244" name="Text 4"/>
           <p:cNvSpPr/>
           <p:nvPr/>
         </p:nvSpPr>
@@ -12381,7 +13209,7 @@
       </p:sp>
       <p:sp>
         <p:nvSpPr>
-          <p:cNvPr id="1373247604" name="Text 5"/>
+          <p:cNvPr id="104652036" name="Text 5"/>
           <p:cNvSpPr/>
           <p:nvPr/>
         </p:nvSpPr>
@@ -12443,7 +13271,7 @@
       </p:sp>
       <p:sp>
         <p:nvSpPr>
-          <p:cNvPr id="1158560829" name="Shape 6"/>
+          <p:cNvPr id="1670982810" name="Shape 6"/>
           <p:cNvSpPr/>
           <p:nvPr/>
         </p:nvSpPr>
@@ -12478,7 +13306,7 @@
       </p:sp>
       <p:sp>
         <p:nvSpPr>
-          <p:cNvPr id="5160309" name="Shape 7"/>
+          <p:cNvPr id="2044524862" name="Shape 7"/>
           <p:cNvSpPr/>
           <p:nvPr/>
         </p:nvSpPr>
@@ -12508,7 +13336,7 @@
       </p:sp>
       <p:sp>
         <p:nvSpPr>
-          <p:cNvPr id="2011722169" name="Text 8"/>
+          <p:cNvPr id="404947914" name="Text 8"/>
           <p:cNvSpPr/>
           <p:nvPr/>
         </p:nvSpPr>
@@ -12548,7 +13376,7 @@
       </p:sp>
       <p:sp>
         <p:nvSpPr>
-          <p:cNvPr id="1957992795" name="Text 9"/>
+          <p:cNvPr id="122175728" name="Text 9"/>
           <p:cNvSpPr/>
           <p:nvPr/>
         </p:nvSpPr>
@@ -12588,7 +13416,7 @@
       </p:sp>
       <p:sp>
         <p:nvSpPr>
-          <p:cNvPr id="417314114" name="Shape 10"/>
+          <p:cNvPr id="709816053" name="Shape 10"/>
           <p:cNvSpPr/>
           <p:nvPr/>
         </p:nvSpPr>
@@ -12623,7 +13451,7 @@
       </p:sp>
       <p:sp>
         <p:nvSpPr>
-          <p:cNvPr id="2020693363" name="Shape 11"/>
+          <p:cNvPr id="1047946382" name="Shape 11"/>
           <p:cNvSpPr/>
           <p:nvPr/>
         </p:nvSpPr>
@@ -12653,7 +13481,7 @@
       </p:sp>
       <p:sp>
         <p:nvSpPr>
-          <p:cNvPr id="1932328590" name="Text 12"/>
+          <p:cNvPr id="910499697" name="Text 12"/>
           <p:cNvSpPr/>
           <p:nvPr/>
         </p:nvSpPr>
@@ -12693,7 +13521,7 @@
       </p:sp>
       <p:sp>
         <p:nvSpPr>
-          <p:cNvPr id="1978256449" name="Text 13"/>
+          <p:cNvPr id="1590825534" name="Text 13"/>
           <p:cNvSpPr/>
           <p:nvPr/>
         </p:nvSpPr>
@@ -12733,7 +13561,7 @@
       </p:sp>
       <p:sp>
         <p:nvSpPr>
-          <p:cNvPr id="1395231843" name="Shape 14"/>
+          <p:cNvPr id="465905597" name="Shape 14"/>
           <p:cNvSpPr/>
           <p:nvPr/>
         </p:nvSpPr>
@@ -12768,7 +13596,7 @@
       </p:sp>
       <p:sp>
         <p:nvSpPr>
-          <p:cNvPr id="186504672" name="Shape 15"/>
+          <p:cNvPr id="1388013962" name="Shape 15"/>
           <p:cNvSpPr/>
           <p:nvPr/>
         </p:nvSpPr>
@@ -12798,7 +13626,7 @@
       </p:sp>
       <p:sp>
         <p:nvSpPr>
-          <p:cNvPr id="1978488594" name="Text 16"/>
+          <p:cNvPr id="1220532244" name="Text 16"/>
           <p:cNvSpPr/>
           <p:nvPr/>
         </p:nvSpPr>
@@ -12838,7 +13666,7 @@
       </p:sp>
       <p:sp>
         <p:nvSpPr>
-          <p:cNvPr id="558111998" name="Text 17"/>
+          <p:cNvPr id="490003497" name="Text 17"/>
           <p:cNvSpPr/>
           <p:nvPr/>
         </p:nvSpPr>
@@ -12940,7 +13768,7 @@
       </p:grpSpPr>
       <p:sp>
         <p:nvSpPr>
-          <p:cNvPr id="1746469816" name="Text 0"/>
+          <p:cNvPr id="1005638091" name="Text 0"/>
           <p:cNvSpPr/>
           <p:nvPr/>
         </p:nvSpPr>
@@ -12980,7 +13808,7 @@
       </p:sp>
       <p:sp>
         <p:nvSpPr>
-          <p:cNvPr id="1176327787" name="Text 24"/>
+          <p:cNvPr id="1724946929" name="Text 24"/>
           <p:cNvSpPr/>
           <p:nvPr/>
         </p:nvSpPr>
@@ -13009,7 +13837,7 @@
       </p:sp>
       <p:sp>
         <p:nvSpPr>
-          <p:cNvPr id="924502360" name="Text 30"/>
+          <p:cNvPr id="1951069133" name="Text 30"/>
           <p:cNvSpPr/>
           <p:nvPr/>
         </p:nvSpPr>
@@ -13038,7 +13866,7 @@
       </p:sp>
       <p:pic>
         <p:nvPicPr>
-          <p:cNvPr id="1903858315" name="Immagine 41"/>
+          <p:cNvPr id="375641513" name="Immagine 41"/>
           <p:cNvPicPr>
             <a:picLocks noChangeAspect="1"/>
           </p:cNvPicPr>
@@ -13065,7 +13893,7 @@
       </p:pic>
       <p:sp>
         <p:nvSpPr>
-          <p:cNvPr id="349647592" name="Shape 1"/>
+          <p:cNvPr id="211978560" name="Shape 1"/>
           <p:cNvSpPr/>
           <p:nvPr/>
         </p:nvSpPr>
@@ -13135,7 +13963,7 @@
       </p:grpSpPr>
       <p:sp>
         <p:nvSpPr>
-          <p:cNvPr id="1094482528" name="Text 0"/>
+          <p:cNvPr id="743577363" name="Text 0"/>
           <p:cNvSpPr/>
           <p:nvPr/>
         </p:nvSpPr>
@@ -13175,7 +14003,7 @@
       </p:sp>
       <p:sp>
         <p:nvSpPr>
-          <p:cNvPr id="1649982452" name="Shape 1"/>
+          <p:cNvPr id="30562354" name="Shape 1"/>
           <p:cNvSpPr/>
           <p:nvPr/>
         </p:nvSpPr>
@@ -13205,7 +14033,7 @@
       </p:sp>
       <p:sp>
         <p:nvSpPr>
-          <p:cNvPr id="988217934" name="Shape 2"/>
+          <p:cNvPr id="1795519111" name="Shape 2"/>
           <p:cNvSpPr/>
           <p:nvPr/>
         </p:nvSpPr>
@@ -13240,7 +14068,7 @@
       </p:sp>
       <p:sp>
         <p:nvSpPr>
-          <p:cNvPr id="150158632" name="Text 3"/>
+          <p:cNvPr id="1327476990" name="Text 3"/>
           <p:cNvSpPr/>
           <p:nvPr/>
         </p:nvSpPr>
@@ -13280,7 +14108,7 @@
       </p:sp>
       <p:sp>
         <p:nvSpPr>
-          <p:cNvPr id="1806641122" name="Shape 4"/>
+          <p:cNvPr id="1657618406" name="Shape 4"/>
           <p:cNvSpPr/>
           <p:nvPr/>
         </p:nvSpPr>
@@ -13310,7 +14138,7 @@
       </p:sp>
       <p:sp>
         <p:nvSpPr>
-          <p:cNvPr id="784332633" name="Text 5"/>
+          <p:cNvPr id="351880698" name="Text 5"/>
           <p:cNvSpPr/>
           <p:nvPr/>
         </p:nvSpPr>
@@ -13350,7 +14178,7 @@
       </p:sp>
       <p:sp>
         <p:nvSpPr>
-          <p:cNvPr id="849953566" name="Text 6"/>
+          <p:cNvPr id="1088173630" name="Text 6"/>
           <p:cNvSpPr/>
           <p:nvPr/>
         </p:nvSpPr>
@@ -13390,7 +14218,7 @@
       </p:sp>
       <p:sp>
         <p:nvSpPr>
-          <p:cNvPr id="1542192565" name="Text 7"/>
+          <p:cNvPr id="1109583465" name="Text 7"/>
           <p:cNvSpPr/>
           <p:nvPr/>
         </p:nvSpPr>
@@ -13452,7 +14280,7 @@
       </p:sp>
       <p:sp>
         <p:nvSpPr>
-          <p:cNvPr id="1712664326" name="Text 8"/>
+          <p:cNvPr id="1358789866" name="Text 8"/>
           <p:cNvSpPr/>
           <p:nvPr/>
         </p:nvSpPr>
@@ -13492,7 +14320,7 @@
       </p:sp>
       <p:sp>
         <p:nvSpPr>
-          <p:cNvPr id="1113106052" name="Shape 9"/>
+          <p:cNvPr id="1820282680" name="Shape 9"/>
           <p:cNvSpPr/>
           <p:nvPr/>
         </p:nvSpPr>
@@ -13527,7 +14355,7 @@
       </p:sp>
       <p:sp>
         <p:nvSpPr>
-          <p:cNvPr id="550388562" name="Text 10"/>
+          <p:cNvPr id="191132456" name="Text 10"/>
           <p:cNvSpPr/>
           <p:nvPr/>
         </p:nvSpPr>
@@ -13567,7 +14395,7 @@
       </p:sp>
       <p:sp>
         <p:nvSpPr>
-          <p:cNvPr id="932231587" name="Shape 11"/>
+          <p:cNvPr id="1186187687" name="Shape 11"/>
           <p:cNvSpPr/>
           <p:nvPr/>
         </p:nvSpPr>
@@ -13597,7 +14425,7 @@
       </p:sp>
       <p:sp>
         <p:nvSpPr>
-          <p:cNvPr id="1275870114" name="Text 12"/>
+          <p:cNvPr id="2108596220" name="Text 12"/>
           <p:cNvSpPr/>
           <p:nvPr/>
         </p:nvSpPr>
@@ -13637,7 +14465,7 @@
       </p:sp>
       <p:sp>
         <p:nvSpPr>
-          <p:cNvPr id="1820941199" name="Text 13"/>
+          <p:cNvPr id="1254891635" name="Text 13"/>
           <p:cNvSpPr/>
           <p:nvPr/>
         </p:nvSpPr>
@@ -13699,7 +14527,7 @@
       </p:sp>
       <p:sp>
         <p:nvSpPr>
-          <p:cNvPr id="1914107210" name="Text 14"/>
+          <p:cNvPr id="342921176" name="Text 14"/>
           <p:cNvSpPr/>
           <p:nvPr/>
         </p:nvSpPr>
@@ -13739,7 +14567,7 @@
       </p:sp>
       <p:sp>
         <p:nvSpPr>
-          <p:cNvPr id="157053710" name="Text 15"/>
+          <p:cNvPr id="1005370097" name="Text 15"/>
           <p:cNvSpPr/>
           <p:nvPr/>
         </p:nvSpPr>
@@ -13779,7 +14607,7 @@
       </p:sp>
       <p:sp>
         <p:nvSpPr>
-          <p:cNvPr id="1393005208" name="Shape 16"/>
+          <p:cNvPr id="2121887939" name="Shape 16"/>
           <p:cNvSpPr/>
           <p:nvPr/>
         </p:nvSpPr>
@@ -13814,7 +14642,7 @@
       </p:sp>
       <p:sp>
         <p:nvSpPr>
-          <p:cNvPr id="1985947292" name="Text 17"/>
+          <p:cNvPr id="975900348" name="Text 17"/>
           <p:cNvSpPr/>
           <p:nvPr/>
         </p:nvSpPr>
@@ -13854,7 +14682,7 @@
       </p:sp>
       <p:sp>
         <p:nvSpPr>
-          <p:cNvPr id="1765900123" name="Shape 18"/>
+          <p:cNvPr id="1744271713" name="Shape 18"/>
           <p:cNvSpPr/>
           <p:nvPr/>
         </p:nvSpPr>
@@ -13884,7 +14712,7 @@
       </p:sp>
       <p:sp>
         <p:nvSpPr>
-          <p:cNvPr id="1656719686" name="Text 19"/>
+          <p:cNvPr id="391210902" name="Text 19"/>
           <p:cNvSpPr/>
           <p:nvPr/>
         </p:nvSpPr>
@@ -13924,7 +14752,7 @@
       </p:sp>
       <p:sp>
         <p:nvSpPr>
-          <p:cNvPr id="1422598258" name="Text 20"/>
+          <p:cNvPr id="1392476972" name="Text 20"/>
           <p:cNvSpPr/>
           <p:nvPr/>
         </p:nvSpPr>
@@ -13986,7 +14814,7 @@
       </p:sp>
       <p:sp>
         <p:nvSpPr>
-          <p:cNvPr id="863069521" name="Text 21"/>
+          <p:cNvPr id="676738367" name="Text 21"/>
           <p:cNvSpPr/>
           <p:nvPr/>
         </p:nvSpPr>
@@ -14026,7 +14854,7 @@
       </p:sp>
       <p:sp>
         <p:nvSpPr>
-          <p:cNvPr id="975244002" name="Text 22"/>
+          <p:cNvPr id="1507461996" name="Text 22"/>
           <p:cNvSpPr/>
           <p:nvPr/>
         </p:nvSpPr>
@@ -14095,7 +14923,7 @@
       </p:grpSpPr>
       <p:sp>
         <p:nvSpPr>
-          <p:cNvPr id="1398437339" name="Text 0"/>
+          <p:cNvPr id="1402797603" name="Text 0"/>
           <p:cNvSpPr/>
           <p:nvPr/>
         </p:nvSpPr>
@@ -14135,7 +14963,7 @@
       </p:sp>
       <p:sp>
         <p:nvSpPr>
-          <p:cNvPr id="186724845" name="Shape 1"/>
+          <p:cNvPr id="829249830" name="Shape 1"/>
           <p:cNvSpPr/>
           <p:nvPr/>
         </p:nvSpPr>
@@ -14165,7 +14993,7 @@
       </p:sp>
       <p:sp>
         <p:nvSpPr>
-          <p:cNvPr id="1925172333" name="Shape 2"/>
+          <p:cNvPr id="1836823967" name="Shape 2"/>
           <p:cNvSpPr/>
           <p:nvPr/>
         </p:nvSpPr>
@@ -14200,7 +15028,7 @@
       </p:sp>
       <p:sp>
         <p:nvSpPr>
-          <p:cNvPr id="914944195" name="Text 3"/>
+          <p:cNvPr id="1964008049" name="Text 3"/>
           <p:cNvSpPr/>
           <p:nvPr/>
         </p:nvSpPr>
@@ -14240,7 +15068,7 @@
       </p:sp>
       <p:sp>
         <p:nvSpPr>
-          <p:cNvPr id="1851155111" name="Text 4"/>
+          <p:cNvPr id="2054126594" name="Text 4"/>
           <p:cNvSpPr/>
           <p:nvPr/>
         </p:nvSpPr>
@@ -14280,7 +15108,7 @@
       </p:sp>
       <p:sp>
         <p:nvSpPr>
-          <p:cNvPr id="491969961" name="Text 5"/>
+          <p:cNvPr id="390164850" name="Text 5"/>
           <p:cNvSpPr/>
           <p:nvPr/>
         </p:nvSpPr>
@@ -14342,7 +15170,7 @@
       </p:sp>
       <p:sp>
         <p:nvSpPr>
-          <p:cNvPr id="1211467931" name="Text 6"/>
+          <p:cNvPr id="1296381110" name="Text 6"/>
           <p:cNvSpPr/>
           <p:nvPr/>
         </p:nvSpPr>
@@ -14382,7 +15210,7 @@
       </p:sp>
       <p:sp>
         <p:nvSpPr>
-          <p:cNvPr id="1070622327" name="Text 7"/>
+          <p:cNvPr id="742701073" name="Text 7"/>
           <p:cNvSpPr/>
           <p:nvPr/>
         </p:nvSpPr>
@@ -14422,7 +15250,7 @@
       </p:sp>
       <p:sp>
         <p:nvSpPr>
-          <p:cNvPr id="1625928749" name="Text 8"/>
+          <p:cNvPr id="1463013701" name="Text 8"/>
           <p:cNvSpPr/>
           <p:nvPr/>
         </p:nvSpPr>
@@ -14462,7 +15290,7 @@
       </p:sp>
       <p:sp>
         <p:nvSpPr>
-          <p:cNvPr id="1355860306" name="Text 9"/>
+          <p:cNvPr id="669968490" name="Text 9"/>
           <p:cNvSpPr/>
           <p:nvPr/>
         </p:nvSpPr>
@@ -14524,7 +15352,7 @@
       </p:sp>
       <p:sp>
         <p:nvSpPr>
-          <p:cNvPr id="1918753949" name="Text 10"/>
+          <p:cNvPr id="1972141548" name="Text 10"/>
           <p:cNvSpPr/>
           <p:nvPr/>
         </p:nvSpPr>
@@ -14564,7 +15392,7 @@
       </p:sp>
       <p:sp>
         <p:nvSpPr>
-          <p:cNvPr id="1650094975" name="Text 11"/>
+          <p:cNvPr id="104052548" name="Text 11"/>
           <p:cNvSpPr/>
           <p:nvPr/>
         </p:nvSpPr>
@@ -14604,7 +15432,7 @@
       </p:sp>
       <p:sp>
         <p:nvSpPr>
-          <p:cNvPr id="143683962" name="Text 12"/>
+          <p:cNvPr id="1564560463" name="Text 12"/>
           <p:cNvSpPr/>
           <p:nvPr/>
         </p:nvSpPr>
@@ -14633,7 +15461,7 @@
       </p:sp>
       <p:sp>
         <p:nvSpPr>
-          <p:cNvPr id="356990458" name="Shape 13"/>
+          <p:cNvPr id="2139003122" name="Shape 13"/>
           <p:cNvSpPr/>
           <p:nvPr/>
         </p:nvSpPr>
@@ -14668,7 +15496,7 @@
       </p:sp>
       <p:sp>
         <p:nvSpPr>
-          <p:cNvPr id="1133299970" name="Text 14"/>
+          <p:cNvPr id="2085747817" name="Text 14"/>
           <p:cNvSpPr/>
           <p:nvPr/>
         </p:nvSpPr>
@@ -14708,7 +15536,7 @@
       </p:sp>
       <p:sp>
         <p:nvSpPr>
-          <p:cNvPr id="992495700" name="Text 15"/>
+          <p:cNvPr id="750999019" name="Text 15"/>
           <p:cNvSpPr/>
           <p:nvPr/>
         </p:nvSpPr>
@@ -14748,7 +15576,7 @@
       </p:sp>
       <p:sp>
         <p:nvSpPr>
-          <p:cNvPr id="1640365445" name="Text 16"/>
+          <p:cNvPr id="1040812025" name="Text 16"/>
           <p:cNvSpPr/>
           <p:nvPr/>
         </p:nvSpPr>
@@ -14810,7 +15638,7 @@
       </p:sp>
       <p:sp>
         <p:nvSpPr>
-          <p:cNvPr id="146915764" name="Text 17"/>
+          <p:cNvPr id="720982071" name="Text 17"/>
           <p:cNvSpPr/>
           <p:nvPr/>
         </p:nvSpPr>
@@ -14850,7 +15678,7 @@
       </p:sp>
       <p:sp>
         <p:nvSpPr>
-          <p:cNvPr id="1005160688" name="Text 18"/>
+          <p:cNvPr id="93218318" name="Text 18"/>
           <p:cNvSpPr/>
           <p:nvPr/>
         </p:nvSpPr>
@@ -14890,7 +15718,7 @@
       </p:sp>
       <p:sp>
         <p:nvSpPr>
-          <p:cNvPr id="1662667618" name="Text 19"/>
+          <p:cNvPr id="1744517707" name="Text 19"/>
           <p:cNvSpPr/>
           <p:nvPr/>
         </p:nvSpPr>
@@ -14930,7 +15758,7 @@
       </p:sp>
       <p:sp>
         <p:nvSpPr>
-          <p:cNvPr id="1243196519" name="Text 20"/>
+          <p:cNvPr id="1476473062" name="Text 20"/>
           <p:cNvSpPr/>
           <p:nvPr/>
         </p:nvSpPr>
@@ -14992,7 +15820,7 @@
       </p:sp>
       <p:sp>
         <p:nvSpPr>
-          <p:cNvPr id="2060036309" name="Text 21"/>
+          <p:cNvPr id="570344958" name="Text 21"/>
           <p:cNvSpPr/>
           <p:nvPr/>
         </p:nvSpPr>
@@ -15032,7 +15860,7 @@
       </p:sp>
       <p:sp>
         <p:nvSpPr>
-          <p:cNvPr id="973880422" name="Text 22"/>
+          <p:cNvPr id="532804055" name="Text 22"/>
           <p:cNvSpPr/>
           <p:nvPr/>
         </p:nvSpPr>
@@ -15072,7 +15900,7 @@
       </p:sp>
       <p:sp>
         <p:nvSpPr>
-          <p:cNvPr id="891610182" name="Text 23"/>
+          <p:cNvPr id="816072832" name="Text 23"/>
           <p:cNvSpPr/>
           <p:nvPr/>
         </p:nvSpPr>
@@ -15101,7 +15929,7 @@
       </p:sp>
       <p:sp>
         <p:nvSpPr>
-          <p:cNvPr id="843253482" name="Text 24"/>
+          <p:cNvPr id="1200861142" name="Text 24"/>
           <p:cNvSpPr/>
           <p:nvPr/>
         </p:nvSpPr>
@@ -15130,7 +15958,7 @@
       </p:sp>
       <p:sp>
         <p:nvSpPr>
-          <p:cNvPr id="1666471183" name="Text 25"/>
+          <p:cNvPr id="601266230" name="Text 25"/>
           <p:cNvSpPr/>
           <p:nvPr/>
         </p:nvSpPr>
@@ -15199,7 +16027,7 @@
       </p:grpSpPr>
       <p:sp>
         <p:nvSpPr>
-          <p:cNvPr id="973589494" name="Text 0"/>
+          <p:cNvPr id="337836505" name="Text 0"/>
           <p:cNvSpPr/>
           <p:nvPr/>
         </p:nvSpPr>
@@ -15261,7 +16089,7 @@
       </p:sp>
       <p:sp>
         <p:nvSpPr>
-          <p:cNvPr id="686837681" name="Text 1"/>
+          <p:cNvPr id="529519752" name="Text 1"/>
           <p:cNvSpPr/>
           <p:nvPr/>
         </p:nvSpPr>
@@ -15290,7 +16118,7 @@
       </p:sp>
       <p:sp>
         <p:nvSpPr>
-          <p:cNvPr id="665896384" name="Text 2"/>
+          <p:cNvPr id="636357855" name="Text 2"/>
           <p:cNvSpPr/>
           <p:nvPr/>
         </p:nvSpPr>
@@ -15319,7 +16147,7 @@
       </p:sp>
       <p:sp>
         <p:nvSpPr>
-          <p:cNvPr id="1059677004" name="Text 1"/>
+          <p:cNvPr id="1860872839" name="Text 1"/>
           <p:cNvSpPr/>
           <p:nvPr/>
         </p:nvSpPr>
@@ -15399,7 +16227,7 @@
       </p:grpSpPr>
       <p:sp>
         <p:nvSpPr>
-          <p:cNvPr id="1493995874" name="Text 0"/>
+          <p:cNvPr id="1186763659" name="Text 0"/>
           <p:cNvSpPr/>
           <p:nvPr/>
         </p:nvSpPr>
@@ -15439,7 +16267,7 @@
       </p:sp>
       <p:sp>
         <p:nvSpPr>
-          <p:cNvPr id="1970596405" name="Shape 1"/>
+          <p:cNvPr id="683329230" name="Shape 1"/>
           <p:cNvSpPr/>
           <p:nvPr/>
         </p:nvSpPr>
@@ -15469,7 +16297,7 @@
       </p:sp>
       <p:sp>
         <p:nvSpPr>
-          <p:cNvPr id="884374650" name="Shape 2"/>
+          <p:cNvPr id="1574855460" name="Shape 2"/>
           <p:cNvSpPr/>
           <p:nvPr/>
         </p:nvSpPr>
@@ -15504,7 +16332,7 @@
       </p:sp>
       <p:sp>
         <p:nvSpPr>
-          <p:cNvPr id="1132638475" name="Text 3"/>
+          <p:cNvPr id="1118558619" name="Text 3"/>
           <p:cNvSpPr/>
           <p:nvPr/>
         </p:nvSpPr>
@@ -15544,7 +16372,7 @@
       </p:sp>
       <p:sp>
         <p:nvSpPr>
-          <p:cNvPr id="1800032250" name="Shape 4"/>
+          <p:cNvPr id="1974748444" name="Shape 4"/>
           <p:cNvSpPr/>
           <p:nvPr/>
         </p:nvSpPr>
@@ -15579,7 +16407,7 @@
       </p:sp>
       <p:sp>
         <p:nvSpPr>
-          <p:cNvPr id="215608562" name="Text 5"/>
+          <p:cNvPr id="677872573" name="Text 5"/>
           <p:cNvSpPr/>
           <p:nvPr/>
         </p:nvSpPr>
@@ -15619,7 +16447,7 @@
       </p:sp>
       <p:sp>
         <p:nvSpPr>
-          <p:cNvPr id="2146447765" name="Shape 6"/>
+          <p:cNvPr id="706276269" name="Shape 6"/>
           <p:cNvSpPr/>
           <p:nvPr/>
         </p:nvSpPr>
@@ -15654,7 +16482,7 @@
       </p:sp>
       <p:sp>
         <p:nvSpPr>
-          <p:cNvPr id="1483189010" name="Text 7"/>
+          <p:cNvPr id="641165888" name="Text 7"/>
           <p:cNvSpPr/>
           <p:nvPr/>
         </p:nvSpPr>
@@ -15694,7 +16522,7 @@
       </p:sp>
       <p:sp>
         <p:nvSpPr>
-          <p:cNvPr id="503798662" name="Shape 8"/>
+          <p:cNvPr id="528790195" name="Shape 8"/>
           <p:cNvSpPr/>
           <p:nvPr/>
         </p:nvSpPr>
@@ -15729,7 +16557,7 @@
       </p:sp>
       <p:sp>
         <p:nvSpPr>
-          <p:cNvPr id="118316378" name="Text 9"/>
+          <p:cNvPr id="1559443354" name="Text 9"/>
           <p:cNvSpPr/>
           <p:nvPr/>
         </p:nvSpPr>
@@ -15769,7 +16597,7 @@
       </p:sp>
       <p:sp>
         <p:nvSpPr>
-          <p:cNvPr id="848728131" name="Shape 10"/>
+          <p:cNvPr id="1287625416" name="Shape 10"/>
           <p:cNvSpPr/>
           <p:nvPr/>
         </p:nvSpPr>
@@ -15804,7 +16632,7 @@
       </p:sp>
       <p:sp>
         <p:nvSpPr>
-          <p:cNvPr id="20374975" name="Text 11"/>
+          <p:cNvPr id="1275835630" name="Text 11"/>
           <p:cNvSpPr/>
           <p:nvPr/>
         </p:nvSpPr>
@@ -15855,7 +16683,7 @@
       </p:sp>
       <p:sp>
         <p:nvSpPr>
-          <p:cNvPr id="2107660052" name="Shape 12"/>
+          <p:cNvPr id="1939995725" name="Shape 12"/>
           <p:cNvSpPr/>
           <p:nvPr/>
         </p:nvSpPr>
@@ -15890,7 +16718,7 @@
       </p:sp>
       <p:sp>
         <p:nvSpPr>
-          <p:cNvPr id="160888194" name="Text 13"/>
+          <p:cNvPr id="1450278526" name="Text 13"/>
           <p:cNvSpPr/>
           <p:nvPr/>
         </p:nvSpPr>
@@ -15930,7 +16758,7 @@
       </p:sp>
       <p:sp>
         <p:nvSpPr>
-          <p:cNvPr id="844653865" name="Shape 14"/>
+          <p:cNvPr id="2019155346" name="Shape 14"/>
           <p:cNvSpPr/>
           <p:nvPr/>
         </p:nvSpPr>
@@ -15965,7 +16793,7 @@
       </p:sp>
       <p:sp>
         <p:nvSpPr>
-          <p:cNvPr id="864422381" name="Text 15"/>
+          <p:cNvPr id="112967426" name="Text 15"/>
           <p:cNvSpPr/>
           <p:nvPr/>
         </p:nvSpPr>
@@ -16005,7 +16833,7 @@
       </p:sp>
       <p:sp>
         <p:nvSpPr>
-          <p:cNvPr id="1411719487" name="Shape 16"/>
+          <p:cNvPr id="90152017" name="Shape 16"/>
           <p:cNvSpPr/>
           <p:nvPr/>
         </p:nvSpPr>
@@ -16040,7 +16868,7 @@
       </p:sp>
       <p:sp>
         <p:nvSpPr>
-          <p:cNvPr id="1117896585" name="Text 17"/>
+          <p:cNvPr id="742755974" name="Text 17"/>
           <p:cNvSpPr/>
           <p:nvPr/>
         </p:nvSpPr>
@@ -16156,7 +16984,7 @@
       </p:sp>
       <p:sp>
         <p:nvSpPr>
-          <p:cNvPr id="1436421761" name="Shape 18"/>
+          <p:cNvPr id="933986529" name="Shape 18"/>
           <p:cNvSpPr/>
           <p:nvPr/>
         </p:nvSpPr>
@@ -16191,7 +17019,7 @@
       </p:sp>
       <p:sp>
         <p:nvSpPr>
-          <p:cNvPr id="65027380" name="Text 19"/>
+          <p:cNvPr id="359088664" name="Text 19"/>
           <p:cNvSpPr/>
           <p:nvPr/>
         </p:nvSpPr>
@@ -16242,7 +17070,7 @@
       </p:sp>
       <p:sp>
         <p:nvSpPr>
-          <p:cNvPr id="1562729340" name="Shape 20"/>
+          <p:cNvPr id="1616532796" name="Shape 20"/>
           <p:cNvSpPr/>
           <p:nvPr/>
         </p:nvSpPr>
@@ -16277,7 +17105,7 @@
       </p:sp>
       <p:sp>
         <p:nvSpPr>
-          <p:cNvPr id="825361042" name="Text 21"/>
+          <p:cNvPr id="304395104" name="Text 21"/>
           <p:cNvSpPr/>
           <p:nvPr/>
         </p:nvSpPr>
@@ -16317,7 +17145,7 @@
       </p:sp>
       <p:sp>
         <p:nvSpPr>
-          <p:cNvPr id="1374775926" name="Shape 22"/>
+          <p:cNvPr id="539501800" name="Shape 22"/>
           <p:cNvSpPr/>
           <p:nvPr/>
         </p:nvSpPr>
@@ -16352,7 +17180,7 @@
       </p:sp>
       <p:sp>
         <p:nvSpPr>
-          <p:cNvPr id="39678532" name="Text 23"/>
+          <p:cNvPr id="1029669388" name="Text 23"/>
           <p:cNvSpPr/>
           <p:nvPr/>
         </p:nvSpPr>
@@ -16392,7 +17220,7 @@
       </p:sp>
       <p:sp>
         <p:nvSpPr>
-          <p:cNvPr id="1927098430" name="Shape 24"/>
+          <p:cNvPr id="508220233" name="Shape 24"/>
           <p:cNvSpPr/>
           <p:nvPr/>
         </p:nvSpPr>
@@ -16427,7 +17255,7 @@
       </p:sp>
       <p:sp>
         <p:nvSpPr>
-          <p:cNvPr id="395382761" name="Text 25"/>
+          <p:cNvPr id="1952965512" name="Text 25"/>
           <p:cNvSpPr/>
           <p:nvPr/>
         </p:nvSpPr>
@@ -16522,7 +17350,7 @@
       </p:sp>
       <p:sp>
         <p:nvSpPr>
-          <p:cNvPr id="119208180" name="Shape 26"/>
+          <p:cNvPr id="1148059192" name="Shape 26"/>
           <p:cNvSpPr/>
           <p:nvPr/>
         </p:nvSpPr>
@@ -16557,7 +17385,7 @@
       </p:sp>
       <p:sp>
         <p:nvSpPr>
-          <p:cNvPr id="1821684620" name="Text 27"/>
+          <p:cNvPr id="639441960" name="Text 27"/>
           <p:cNvSpPr/>
           <p:nvPr/>
         </p:nvSpPr>
@@ -16608,7 +17436,7 @@
       </p:sp>
       <p:sp>
         <p:nvSpPr>
-          <p:cNvPr id="1629134471" name="Shape 28"/>
+          <p:cNvPr id="1111193462" name="Shape 28"/>
           <p:cNvSpPr/>
           <p:nvPr/>
         </p:nvSpPr>
@@ -16643,7 +17471,7 @@
       </p:sp>
       <p:sp>
         <p:nvSpPr>
-          <p:cNvPr id="83508160" name="Text 29"/>
+          <p:cNvPr id="1211020085" name="Text 29"/>
           <p:cNvSpPr/>
           <p:nvPr/>
         </p:nvSpPr>
@@ -16683,7 +17511,7 @@
       </p:sp>
       <p:sp>
         <p:nvSpPr>
-          <p:cNvPr id="144503953" name="Shape 30"/>
+          <p:cNvPr id="873825360" name="Shape 30"/>
           <p:cNvSpPr/>
           <p:nvPr/>
         </p:nvSpPr>
@@ -16718,7 +17546,7 @@
       </p:sp>
       <p:sp>
         <p:nvSpPr>
-          <p:cNvPr id="1641496016" name="Text 31"/>
+          <p:cNvPr id="76924756" name="Text 31"/>
           <p:cNvSpPr/>
           <p:nvPr/>
         </p:nvSpPr>
@@ -16758,7 +17586,7 @@
       </p:sp>
       <p:sp>
         <p:nvSpPr>
-          <p:cNvPr id="210614835" name="Shape 32"/>
+          <p:cNvPr id="208197850" name="Shape 32"/>
           <p:cNvSpPr/>
           <p:nvPr/>
         </p:nvSpPr>
@@ -16793,7 +17621,7 @@
       </p:sp>
       <p:sp>
         <p:nvSpPr>
-          <p:cNvPr id="1067469889" name="Text 33"/>
+          <p:cNvPr id="1632757933" name="Text 33"/>
           <p:cNvSpPr/>
           <p:nvPr/>
         </p:nvSpPr>
@@ -16844,7 +17672,7 @@
       </p:sp>
       <p:sp>
         <p:nvSpPr>
-          <p:cNvPr id="313316586" name="Shape 34"/>
+          <p:cNvPr id="139730003" name="Shape 34"/>
           <p:cNvSpPr/>
           <p:nvPr/>
         </p:nvSpPr>
@@ -16879,7 +17707,7 @@
       </p:sp>
       <p:sp>
         <p:nvSpPr>
-          <p:cNvPr id="733820799" name="Text 35"/>
+          <p:cNvPr id="568035595" name="Text 35"/>
           <p:cNvSpPr/>
           <p:nvPr/>
         </p:nvSpPr>
@@ -16919,7 +17747,7 @@
       </p:sp>
       <p:sp>
         <p:nvSpPr>
-          <p:cNvPr id="1022002167" name="Shape 36"/>
+          <p:cNvPr id="1801335460" name="Shape 36"/>
           <p:cNvSpPr/>
           <p:nvPr/>
         </p:nvSpPr>
@@ -16954,7 +17782,7 @@
       </p:sp>
       <p:sp>
         <p:nvSpPr>
-          <p:cNvPr id="893667956" name="Text 37"/>
+          <p:cNvPr id="573431458" name="Text 37"/>
           <p:cNvSpPr/>
           <p:nvPr/>
         </p:nvSpPr>
@@ -17005,7 +17833,7 @@
       </p:sp>
       <p:sp>
         <p:nvSpPr>
-          <p:cNvPr id="2025872863" name="Shape 38"/>
+          <p:cNvPr id="165053705" name="Shape 38"/>
           <p:cNvSpPr/>
           <p:nvPr/>
         </p:nvSpPr>
@@ -17040,7 +17868,7 @@
       </p:sp>
       <p:sp>
         <p:nvSpPr>
-          <p:cNvPr id="765387054" name="Text 39"/>
+          <p:cNvPr id="2100197340" name="Text 39"/>
           <p:cNvSpPr/>
           <p:nvPr/>
         </p:nvSpPr>
@@ -17080,7 +17908,7 @@
       </p:sp>
       <p:sp>
         <p:nvSpPr>
-          <p:cNvPr id="907031996" name="Shape 40"/>
+          <p:cNvPr id="470374539" name="Shape 40"/>
           <p:cNvSpPr/>
           <p:nvPr/>
         </p:nvSpPr>
@@ -17115,7 +17943,7 @@
       </p:sp>
       <p:sp>
         <p:nvSpPr>
-          <p:cNvPr id="1593478844" name="Text 41"/>
+          <p:cNvPr id="2065506043" name="Text 41"/>
           <p:cNvSpPr/>
           <p:nvPr/>
         </p:nvSpPr>
@@ -17188,7 +18016,7 @@
       </p:sp>
       <p:sp>
         <p:nvSpPr>
-          <p:cNvPr id="1075885197" name="Text 42"/>
+          <p:cNvPr id="1039207794" name="Text 42"/>
           <p:cNvSpPr/>
           <p:nvPr/>
         </p:nvSpPr>
@@ -17257,7 +18085,7 @@
       </p:grpSpPr>
       <p:sp>
         <p:nvSpPr>
-          <p:cNvPr id="1391316665" name="Text 0"/>
+          <p:cNvPr id="1627412332" name="Text 0"/>
           <p:cNvSpPr/>
           <p:nvPr/>
         </p:nvSpPr>
@@ -17297,7 +18125,7 @@
       </p:sp>
       <p:sp>
         <p:nvSpPr>
-          <p:cNvPr id="1912535661" name="Shape 1"/>
+          <p:cNvPr id="868705947" name="Shape 1"/>
           <p:cNvSpPr/>
           <p:nvPr/>
         </p:nvSpPr>
@@ -17327,7 +18155,7 @@
       </p:sp>
       <p:sp>
         <p:nvSpPr>
-          <p:cNvPr id="775100229" name="Shape 2"/>
+          <p:cNvPr id="67592993" name="Shape 2"/>
           <p:cNvSpPr/>
           <p:nvPr/>
         </p:nvSpPr>
@@ -17362,7 +18190,7 @@
       </p:sp>
       <p:sp>
         <p:nvSpPr>
-          <p:cNvPr id="1621738107" name="Text 3"/>
+          <p:cNvPr id="782769866" name="Text 3"/>
           <p:cNvSpPr/>
           <p:nvPr/>
         </p:nvSpPr>
@@ -17402,7 +18230,7 @@
       </p:sp>
       <p:sp>
         <p:nvSpPr>
-          <p:cNvPr id="1148442585" name="Shape 4"/>
+          <p:cNvPr id="223052451" name="Shape 4"/>
           <p:cNvSpPr/>
           <p:nvPr/>
         </p:nvSpPr>
@@ -17437,7 +18265,7 @@
       </p:sp>
       <p:sp>
         <p:nvSpPr>
-          <p:cNvPr id="1744501253" name="Text 5"/>
+          <p:cNvPr id="1745903175" name="Text 5"/>
           <p:cNvSpPr/>
           <p:nvPr/>
         </p:nvSpPr>
@@ -17477,7 +18305,7 @@
       </p:sp>
       <p:sp>
         <p:nvSpPr>
-          <p:cNvPr id="460695486" name="Shape 6"/>
+          <p:cNvPr id="1709248165" name="Shape 6"/>
           <p:cNvSpPr/>
           <p:nvPr/>
         </p:nvSpPr>
@@ -17512,7 +18340,7 @@
       </p:sp>
       <p:sp>
         <p:nvSpPr>
-          <p:cNvPr id="2050961320" name="Text 7"/>
+          <p:cNvPr id="543400296" name="Text 7"/>
           <p:cNvSpPr/>
           <p:nvPr/>
         </p:nvSpPr>
@@ -17552,7 +18380,7 @@
       </p:sp>
       <p:sp>
         <p:nvSpPr>
-          <p:cNvPr id="218509527" name="Shape 8"/>
+          <p:cNvPr id="451302702" name="Shape 8"/>
           <p:cNvSpPr/>
           <p:nvPr/>
         </p:nvSpPr>
@@ -17587,7 +18415,7 @@
       </p:sp>
       <p:sp>
         <p:nvSpPr>
-          <p:cNvPr id="2138283786" name="Text 9"/>
+          <p:cNvPr id="854330110" name="Text 9"/>
           <p:cNvSpPr/>
           <p:nvPr/>
         </p:nvSpPr>
@@ -17627,7 +18455,7 @@
       </p:sp>
       <p:sp>
         <p:nvSpPr>
-          <p:cNvPr id="414677884" name="Shape 10"/>
+          <p:cNvPr id="1769544355" name="Shape 10"/>
           <p:cNvSpPr/>
           <p:nvPr/>
         </p:nvSpPr>
@@ -17662,7 +18490,7 @@
       </p:sp>
       <p:sp>
         <p:nvSpPr>
-          <p:cNvPr id="2124037517" name="Text 11"/>
+          <p:cNvPr id="26793059" name="Text 11"/>
           <p:cNvSpPr/>
           <p:nvPr/>
         </p:nvSpPr>
@@ -17720,7 +18548,7 @@
       </p:sp>
       <p:sp>
         <p:nvSpPr>
-          <p:cNvPr id="700739712" name="Shape 12"/>
+          <p:cNvPr id="268969913" name="Shape 12"/>
           <p:cNvSpPr/>
           <p:nvPr/>
         </p:nvSpPr>
@@ -17755,7 +18583,7 @@
       </p:sp>
       <p:sp>
         <p:nvSpPr>
-          <p:cNvPr id="2015214618" name="Text 13"/>
+          <p:cNvPr id="924979861" name="Text 13"/>
           <p:cNvSpPr/>
           <p:nvPr/>
         </p:nvSpPr>
@@ -17795,7 +18623,7 @@
       </p:sp>
       <p:sp>
         <p:nvSpPr>
-          <p:cNvPr id="1657540169" name="Shape 14"/>
+          <p:cNvPr id="13798968" name="Shape 14"/>
           <p:cNvSpPr/>
           <p:nvPr/>
         </p:nvSpPr>
@@ -17830,7 +18658,7 @@
       </p:sp>
       <p:sp>
         <p:nvSpPr>
-          <p:cNvPr id="298935552" name="Text 15"/>
+          <p:cNvPr id="1655464366" name="Text 15"/>
           <p:cNvSpPr/>
           <p:nvPr/>
         </p:nvSpPr>
@@ -17932,7 +18760,7 @@
       </p:sp>
       <p:sp>
         <p:nvSpPr>
-          <p:cNvPr id="1580608229" name="Shape 16"/>
+          <p:cNvPr id="1561890535" name="Shape 16"/>
           <p:cNvSpPr/>
           <p:nvPr/>
         </p:nvSpPr>
@@ -17967,7 +18795,7 @@
       </p:sp>
       <p:sp>
         <p:nvSpPr>
-          <p:cNvPr id="1792191284" name="Text 17"/>
+          <p:cNvPr id="1074169007" name="Text 17"/>
           <p:cNvSpPr/>
           <p:nvPr/>
         </p:nvSpPr>
@@ -18192,7 +19020,7 @@
       </p:sp>
       <p:sp>
         <p:nvSpPr>
-          <p:cNvPr id="292895066" name="Shape 18"/>
+          <p:cNvPr id="2097580143" name="Shape 18"/>
           <p:cNvSpPr/>
           <p:nvPr/>
         </p:nvSpPr>
@@ -18227,7 +19055,7 @@
       </p:sp>
       <p:sp>
         <p:nvSpPr>
-          <p:cNvPr id="614841042" name="Text 19"/>
+          <p:cNvPr id="1253515629" name="Text 19"/>
           <p:cNvSpPr/>
           <p:nvPr/>
         </p:nvSpPr>
@@ -18285,7 +19113,7 @@
       </p:sp>
       <p:sp>
         <p:nvSpPr>
-          <p:cNvPr id="954542394" name="Shape 20"/>
+          <p:cNvPr id="272988781" name="Shape 20"/>
           <p:cNvSpPr/>
           <p:nvPr/>
         </p:nvSpPr>
@@ -18320,7 +19148,7 @@
       </p:sp>
       <p:sp>
         <p:nvSpPr>
-          <p:cNvPr id="1290429031" name="Text 21"/>
+          <p:cNvPr id="774070349" name="Text 21"/>
           <p:cNvSpPr/>
           <p:nvPr/>
         </p:nvSpPr>
@@ -18360,7 +19188,7 @@
       </p:sp>
       <p:sp>
         <p:nvSpPr>
-          <p:cNvPr id="1426431664" name="Shape 22"/>
+          <p:cNvPr id="948098601" name="Shape 22"/>
           <p:cNvSpPr/>
           <p:nvPr/>
         </p:nvSpPr>
@@ -18395,7 +19223,7 @@
       </p:sp>
       <p:sp>
         <p:nvSpPr>
-          <p:cNvPr id="621825463" name="Text 23"/>
+          <p:cNvPr id="1789141154" name="Text 23"/>
           <p:cNvSpPr/>
           <p:nvPr/>
         </p:nvSpPr>
@@ -18497,7 +19325,7 @@
       </p:sp>
       <p:sp>
         <p:nvSpPr>
-          <p:cNvPr id="919098144" name="Shape 24"/>
+          <p:cNvPr id="639852824" name="Shape 24"/>
           <p:cNvSpPr/>
           <p:nvPr/>
         </p:nvSpPr>
@@ -18532,7 +19360,7 @@
       </p:sp>
       <p:sp>
         <p:nvSpPr>
-          <p:cNvPr id="1961581113" name="Text 25"/>
+          <p:cNvPr id="1294596966" name="Text 25"/>
           <p:cNvSpPr/>
           <p:nvPr/>
         </p:nvSpPr>
@@ -18627,7 +19455,7 @@
       </p:sp>
       <p:sp>
         <p:nvSpPr>
-          <p:cNvPr id="880568188" name="Shape 26"/>
+          <p:cNvPr id="980807932" name="Shape 26"/>
           <p:cNvSpPr/>
           <p:nvPr/>
         </p:nvSpPr>
@@ -18662,7 +19490,7 @@
       </p:sp>
       <p:sp>
         <p:nvSpPr>
-          <p:cNvPr id="180675057" name="Text 27"/>
+          <p:cNvPr id="188754047" name="Text 27"/>
           <p:cNvSpPr/>
           <p:nvPr/>
         </p:nvSpPr>
@@ -18720,7 +19548,7 @@
       </p:sp>
       <p:sp>
         <p:nvSpPr>
-          <p:cNvPr id="831128443" name="Shape 28"/>
+          <p:cNvPr id="1608839020" name="Shape 28"/>
           <p:cNvSpPr/>
           <p:nvPr/>
         </p:nvSpPr>
@@ -18755,7 +19583,7 @@
       </p:sp>
       <p:sp>
         <p:nvSpPr>
-          <p:cNvPr id="671258179" name="Text 29"/>
+          <p:cNvPr id="1000283240" name="Text 29"/>
           <p:cNvSpPr/>
           <p:nvPr/>
         </p:nvSpPr>
@@ -18795,7 +19623,7 @@
       </p:sp>
       <p:sp>
         <p:nvSpPr>
-          <p:cNvPr id="768014270" name="Shape 30"/>
+          <p:cNvPr id="200263514" name="Shape 30"/>
           <p:cNvSpPr/>
           <p:nvPr/>
         </p:nvSpPr>
@@ -18830,7 +19658,7 @@
       </p:sp>
       <p:sp>
         <p:nvSpPr>
-          <p:cNvPr id="2134279098" name="Text 31"/>
+          <p:cNvPr id="388554372" name="Text 31"/>
           <p:cNvSpPr/>
           <p:nvPr/>
         </p:nvSpPr>
@@ -18920,7 +19748,7 @@
       </p:sp>
       <p:sp>
         <p:nvSpPr>
-          <p:cNvPr id="2124889806" name="Shape 32"/>
+          <p:cNvPr id="353512486" name="Shape 32"/>
           <p:cNvSpPr/>
           <p:nvPr/>
         </p:nvSpPr>
@@ -18955,7 +19783,7 @@
       </p:sp>
       <p:sp>
         <p:nvSpPr>
-          <p:cNvPr id="1472575847" name="Text 33"/>
+          <p:cNvPr id="546983195" name="Text 33"/>
           <p:cNvSpPr/>
           <p:nvPr/>
         </p:nvSpPr>
@@ -19192,7 +20020,7 @@
       </p:sp>
       <p:sp>
         <p:nvSpPr>
-          <p:cNvPr id="1152855111" name="Text 34"/>
+          <p:cNvPr id="69191390" name="Text 34"/>
           <p:cNvSpPr/>
           <p:nvPr/>
         </p:nvSpPr>

</xml_diff>